<commit_message>
HOD deck: 4 slides (Summary, Money, FTE, Productivity), no repeated project names, in-progress work tagged POTENTIAL
The two added projects are no longer highlighted or named; the Paradeep cost, value and payback box is gone.

Co-Authored-By: Claude Sonnet 5.5 <noreply@anthropic.com>
Claude-Session: https://claude.ai/code/session_01Bi8jGZngCKmVvuqhjQxHzc
</commit_message>
<xml_diff>
--- a/SW_CostModel/docs/CA_Benefits_Nov2025-Oct2026_HOD.pptx
+++ b/SW_CostModel/docs/CA_Benefits_Nov2025-Oct2026_HOD.pptx
@@ -9,10 +9,9 @@
     <p:sldId id="257" r:id="rId3"/>
     <p:sldId id="258" r:id="rId4"/>
     <p:sldId id="259" r:id="rId5"/>
-    <p:sldId id="260" r:id="rId6"/>
   </p:sldIdLst>
   <p:notesMasterIdLst>
-    <p:notesMasterId r:id="rId7"/>
+    <p:notesMasterId r:id="rId6"/>
   </p:notesMasterIdLst>
   <p:sldSz cx="12192000" cy="6858000"/>
   <p:notesSz cx="6858000" cy="12192000"/>
@@ -181,7 +180,7 @@
                     <c:v>In progress (66)</c:v>
                   </c:pt>
                   <c:pt idx="2">
-                    <c:v>All 120 listed</c:v>
+                    <c:v>All 120</c:v>
                   </c:pt>
                 </c:lvl>
               </c:multiLvlStrCache>
@@ -264,7 +263,7 @@
                     <c:v>In progress (66)</c:v>
                   </c:pt>
                   <c:pt idx="2">
-                    <c:v>All 120 listed</c:v>
+                    <c:v>All 120</c:v>
                   </c:pt>
                 </c:lvl>
               </c:multiLvlStrCache>
@@ -464,6 +463,259 @@
               <c:strCache>
                 <c:ptCount val="1"/>
                 <c:pt idx="0">
+                  <c:v>Avoided, ₹ Cr</c:v>
+                </c:pt>
+              </c:strCache>
+            </c:strRef>
+          </c:tx>
+          <c:spPr>
+            <a:solidFill>
+              <a:srgbClr val="1F7A45"/>
+            </a:solidFill>
+            <a:effectLst/>
+          </c:spPr>
+          <c:invertIfNegative val="0"/>
+          <c:dLbls>
+            <c:numFmt formatCode="0.0" sourceLinked="0"/>
+            <c:txPr>
+              <a:bodyPr/>
+              <a:lstStyle/>
+              <a:p>
+                <a:pPr>
+                  <a:defRPr b="0" i="0" strike="noStrike" sz="1200" u="none">
+                    <a:solidFill>
+                      <a:srgbClr val="15222A"/>
+                    </a:solidFill>
+                    <a:latin typeface="Calibri"/>
+                  </a:defRPr>
+                </a:pPr>
+              </a:p>
+            </c:txPr>
+            <c:showLegendKey val="0"/>
+            <c:showVal val="1"/>
+            <c:showCatName val="0"/>
+            <c:showSerName val="0"/>
+            <c:showPercent val="0"/>
+            <c:showBubbleSize val="0"/>
+            <c:showLeaderLines val="0"/>
+          </c:dLbls>
+          <c:cat>
+            <c:multiLvlStrRef>
+              <c:f>Sheet1!$A$2:$A$8</c:f>
+              <c:multiLvlStrCache>
+                <c:ptCount val="7"/>
+                <c:lvl>
+                  <c:pt idx="0">
+                    <c:v>Productivity (39)</c:v>
+                  </c:pt>
+                  <c:pt idx="1">
+                    <c:v>Quality (23)</c:v>
+                  </c:pt>
+                  <c:pt idx="2">
+                    <c:v>Reliability (22)</c:v>
+                  </c:pt>
+                  <c:pt idx="3">
+                    <c:v>Others (21)</c:v>
+                  </c:pt>
+                  <c:pt idx="4">
+                    <c:v>Sustainability (5)</c:v>
+                  </c:pt>
+                  <c:pt idx="5">
+                    <c:v>Workforce optimisation (6)</c:v>
+                  </c:pt>
+                  <c:pt idx="6">
+                    <c:v>HSE and safety (4)</c:v>
+                  </c:pt>
+                </c:lvl>
+              </c:multiLvlStrCache>
+            </c:multiLvlStrRef>
+          </c:cat>
+          <c:val>
+            <c:numRef>
+              <c:f>Sheet1!$B$2:$B$8</c:f>
+              <c:numCache>
+                <c:formatCode>General</c:formatCode>
+                <c:ptCount val="7"/>
+                <c:pt idx="0">
+                  <c:v>12.6</c:v>
+                </c:pt>
+                <c:pt idx="1">
+                  <c:v>6.6</c:v>
+                </c:pt>
+                <c:pt idx="2">
+                  <c:v>4.7</c:v>
+                </c:pt>
+                <c:pt idx="3">
+                  <c:v>4.1</c:v>
+                </c:pt>
+                <c:pt idx="4">
+                  <c:v>3.6</c:v>
+                </c:pt>
+                <c:pt idx="5">
+                  <c:v>2.1</c:v>
+                </c:pt>
+                <c:pt idx="6">
+                  <c:v>0.9</c:v>
+                </c:pt>
+              </c:numCache>
+            </c:numRef>
+          </c:val>
+        </c:ser>
+        <c:dLbls>
+          <c:numFmt formatCode="0.0" sourceLinked="0"/>
+          <c:txPr>
+            <a:bodyPr/>
+            <a:lstStyle/>
+            <a:p>
+              <a:pPr>
+                <a:defRPr b="0" i="0" strike="noStrike" sz="1200" u="none">
+                  <a:solidFill>
+                    <a:srgbClr val="15222A"/>
+                  </a:solidFill>
+                  <a:latin typeface="Calibri"/>
+                </a:defRPr>
+              </a:pPr>
+            </a:p>
+          </c:txPr>
+          <c:showLegendKey val="0"/>
+          <c:showVal val="1"/>
+          <c:showCatName val="0"/>
+          <c:showSerName val="0"/>
+          <c:showPercent val="0"/>
+          <c:showBubbleSize val="0"/>
+          <c:showLeaderLines val="0"/>
+        </c:dLbls>
+        <c:gapWidth val="40"/>
+        <c:overlap val="0"/>
+        <c:axId val="2094734554"/>
+        <c:axId val="2094734552"/>
+        <c:axId val="2094734556"/>
+      </c:barChart>
+      <c:catAx>
+        <c:axId val="2094734554"/>
+        <c:scaling>
+          <c:orientation val="maxMin"/>
+        </c:scaling>
+        <c:delete val="0"/>
+        <c:axPos val="l"/>
+        <c:numFmt formatCode="General" sourceLinked="1"/>
+        <c:majorTickMark val="out"/>
+        <c:minorTickMark val="none"/>
+        <c:tickLblPos val="nextTo"/>
+        <c:spPr>
+          <a:ln w="12700" cap="flat">
+            <a:solidFill>
+              <a:srgbClr val="888888"/>
+            </a:solidFill>
+            <a:prstDash val="solid"/>
+            <a:round/>
+          </a:ln>
+        </c:spPr>
+        <c:txPr>
+          <a:bodyPr/>
+          <a:lstStyle/>
+          <a:p>
+            <a:pPr>
+              <a:defRPr sz="1200" b="0" i="0" u="none" strike="noStrike">
+                <a:solidFill>
+                  <a:srgbClr val="566872"/>
+                </a:solidFill>
+                <a:latin typeface="Calibri"/>
+              </a:defRPr>
+            </a:pPr>
+            <a:endParaRPr lang="en-US"/>
+          </a:p>
+        </c:txPr>
+        <c:crossAx val="2094734552"/>
+        <c:crosses val="autoZero"/>
+        <c:auto val="1"/>
+        <c:lblAlgn val="ctr"/>
+        <c:noMultiLvlLbl val="1"/>
+      </c:catAx>
+      <c:valAx>
+        <c:axId val="2094734552"/>
+        <c:scaling>
+          <c:orientation val="minMax"/>
+        </c:scaling>
+        <c:delete val="1"/>
+        <c:axPos val="b"/>
+        <c:numFmt formatCode="General" sourceLinked="0"/>
+        <c:majorTickMark val="out"/>
+        <c:minorTickMark val="none"/>
+        <c:tickLblPos val="low"/>
+        <c:spPr>
+          <a:ln w="12700" cap="flat">
+            <a:solidFill>
+              <a:srgbClr val="888888"/>
+            </a:solidFill>
+            <a:prstDash val="solid"/>
+            <a:round/>
+          </a:ln>
+        </c:spPr>
+        <c:txPr>
+          <a:bodyPr/>
+          <a:lstStyle/>
+          <a:p>
+            <a:pPr>
+              <a:defRPr sz="1100" b="0" i="0" u="none" strike="noStrike">
+                <a:solidFill>
+                  <a:srgbClr val="566872"/>
+                </a:solidFill>
+                <a:latin typeface="Calibri"/>
+              </a:defRPr>
+            </a:pPr>
+            <a:endParaRPr lang="en-US"/>
+          </a:p>
+        </c:txPr>
+        <c:crossAx val="2094734554"/>
+        <c:crosses val="autoZero"/>
+        <c:crossBetween val="between"/>
+      </c:valAx>
+      <c:spPr>
+        <a:noFill/>
+        <a:ln>
+          <a:noFill/>
+        </a:ln>
+        <a:effectLst/>
+      </c:spPr>
+    </c:plotArea>
+    <c:plotVisOnly val="1"/>
+    <c:dispBlanksAs val="span"/>
+  </c:chart>
+  <c:spPr>
+    <a:noFill/>
+    <a:ln>
+      <a:noFill/>
+    </a:ln>
+    <a:effectLst/>
+  </c:spPr>
+  <c:externalData r:id="rId1">
+    <c:autoUpdate val="0"/>
+  </c:externalData>
+</c:chartSpace>
+</file>
+
+<file path=ppt/charts/chart3.xml><?xml version="1.0" encoding="utf-8"?>
+<c:chartSpace xmlns:c="http://schemas.openxmlformats.org/drawingml/2006/chart" xmlns:a="http://schemas.openxmlformats.org/drawingml/2006/main" xmlns:r="http://schemas.openxmlformats.org/officeDocument/2006/relationships">
+  <c:date1904 val="0"/>
+  <c:roundedCorners val="1"/>
+  <c:chart>
+    <c:autoTitleDeleted val="1"/>
+    <c:plotArea>
+      <c:layout/>
+      <c:barChart>
+        <c:barDir val="bar"/>
+        <c:grouping val="clustered"/>
+        <c:varyColors val="0"/>
+        <c:ser>
+          <c:idx val="0"/>
+          <c:order val="0"/>
+          <c:tx>
+            <c:strRef>
+              <c:f>Sheet1!$B$1</c:f>
+              <c:strCache>
+                <c:ptCount val="1"/>
+                <c:pt idx="0">
                   <c:v>Less effort, %</c:v>
                 </c:pt>
               </c:strCache>
@@ -507,10 +759,10 @@
                 <c:ptCount val="3"/>
                 <c:lvl>
                   <c:pt idx="0">
-                    <c:v>Paradeep: assessment per shipment</c:v>
+                    <c:v>Shipment assessment</c:v>
                   </c:pt>
                   <c:pt idx="1">
-                    <c:v>Slab identification</c:v>
+                    <c:v>Non-prime slab identification</c:v>
                   </c:pt>
                   <c:pt idx="2">
                     <c:v>Report preparation</c:v>
@@ -672,7 +924,7 @@
 </c:chartSpace>
 </file>
 
-<file path=ppt/charts/chart3.xml><?xml version="1.0" encoding="utf-8"?>
+<file path=ppt/charts/chart4.xml><?xml version="1.0" encoding="utf-8"?>
 <c:chartSpace xmlns:c="http://schemas.openxmlformats.org/drawingml/2006/chart" xmlns:a="http://schemas.openxmlformats.org/drawingml/2006/main" xmlns:r="http://schemas.openxmlformats.org/officeDocument/2006/relationships">
   <c:date1904 val="0"/>
   <c:roundedCorners val="1"/>
@@ -736,16 +988,16 @@
                 <c:ptCount val="4"/>
                 <c:lvl>
                   <c:pt idx="0">
-                    <c:v>Coil tracing: 160 min → 10 s</c:v>
+                    <c:v>Yard Management: 160 minutes → 10 seconds</c:v>
                   </c:pt>
                   <c:pt idx="1">
-                    <c:v>SCM commitment report: 4 days → 3 min</c:v>
+                    <c:v>Commitment Report: 4 days → 3 minutes</c:v>
                   </c:pt>
                   <c:pt idx="2">
-                    <c:v>Quality KPI capture: 3 days → 1 h</c:v>
+                    <c:v>QRM: 3 days → 1 hour</c:v>
                   </c:pt>
                   <c:pt idx="3">
-                    <c:v>Manpower distribution: 5 h → 1 h</c:v>
+                    <c:v>CRMS: 5 hours → 1 hour</c:v>
                   </c:pt>
                 </c:lvl>
               </c:multiLvlStrCache>
@@ -907,7 +1159,7 @@
 </c:chartSpace>
 </file>
 
-<file path=ppt/charts/chart4.xml><?xml version="1.0" encoding="utf-8"?>
+<file path=ppt/charts/chart5.xml><?xml version="1.0" encoding="utf-8"?>
 <c:chartSpace xmlns:c="http://schemas.openxmlformats.org/drawingml/2006/chart" xmlns:a="http://schemas.openxmlformats.org/drawingml/2006/main" xmlns:r="http://schemas.openxmlformats.org/officeDocument/2006/relationships">
   <c:date1904 val="0"/>
   <c:roundedCorners val="1"/>
@@ -935,7 +1187,7 @@
           </c:tx>
           <c:spPr>
             <a:solidFill>
-              <a:srgbClr val="C98A00"/>
+              <a:srgbClr val="0D5E72"/>
             </a:solidFill>
             <a:effectLst/>
           </c:spPr>
@@ -1525,7 +1777,7 @@
           <a:p>
             <a:r>
               <a:rPr lang="en-US" dirty="0"/>
-              <a:t>Scope: listed projects whose dates overlap Nov 2025 to 29 October 2026, plus every project marked In Progress (dated outside the period, or with no dates); failed projects left out. 2 projects were added by the owners and are counted but not costed with the estimator (SMP2 gave no cost, Paradeep gave its actual cost). Money = benchmark (software company) cost minus in-house cost over 3 years, for the listed projects only.</a:t>
+              <a:t>Scope: listed projects whose dates overlap Nov 2025 to 29 October 2026, plus every project marked In Progress (dated outside the period, or with no dates); failed projects left out. 2 projects were added by their owners and are counted, but not costed with the estimator. Money = software-company (benchmark) cost minus in-house cost over 3 years, for the listed projects only. FTE = hours / 2,740.</a:t>
             </a:r>
             <a:endParaRPr lang="en-US" dirty="0"/>
           </a:p>
@@ -1613,7 +1865,7 @@
           <a:p>
             <a:r>
               <a:rPr lang="en-US" dirty="0"/>
-              <a:t>In-house ₹43.88 Cr against ₹78.60 Cr for all 120 listed projects; live ₹21.04 Cr against ₹38.52 Cr; in progress ₹22.84 Cr against ₹40.08 Cr. Paradeep Ports: cost ₹17.0 L as given by the owner; 600 h / 8 = 75 man-days x 6,000 (Mid rate in the masters) = ₹4.5 L a year; payback 3.78 years. This is a simple payback on time value only.</a:t>
+              <a:t>In-house ₹43.88 Cr against ₹78.60 Cr for all 120 listed projects; live ₹21.04 Cr against ₹38.52 Cr; in progress ₹22.84 Cr against ₹40.08 Cr. Derived, not recorded: the project list holds no costs, so each listed project is costed with the estimator's standard assumptions (one person, Senior for AI / ML / vision models else Mid; working days between its dates, 90 if a date is missing; 100 users; default masters; 3 years; full project cost, not pro-rated). Same effort on both sides: the difference is in-house rates, loadings and mark-up against a software company's. It is external price avoided, not cash released. The two stated gains are quoted from the list and are not annualised.</a:t>
             </a:r>
             <a:endParaRPr lang="en-US" dirty="0"/>
           </a:p>
@@ -1701,7 +1953,7 @@
           <a:p>
             <a:r>
               <a:rPr lang="en-US" dirty="0"/>
-              <a:t>Paradeep Ports: manual assessment per shipment 360 min to 60 min = 83.3% less; 36,000 min a year = 600 man-hours (owner's figures). 600 / 2,740 = 0.219 FTE. Slab: 7 man-days to 1 = 6 man-days = 48 h saved per slab; 57 slabs a year equal 1 FTE. Report preparation: 4 h to 2 min saves about 3.97 h; 691 reports a year equal 1 FTE.</a:t>
+              <a:t>Shipment assessment: 360 min to 60 min = 83.3% less; 36,000 min a year = 600 man-hours (owner's figures); 600 / 2,740 = 0.219 FTE; about 120 shipments a year follows from 36,000 / 300 (derived). Slab identification: 7 man-days to 1 = 6 man-days = 48 h per slab; 57 slabs a year equal 1 FTE. Report preparation: 4 h to 2 min saves about 3.97 h; 691 reports a year equal 1 FTE. In-house effort: 13,783 person-days x 8 h / 2,740 = 40.2 FTE-years.</a:t>
             </a:r>
             <a:endParaRPr lang="en-US" dirty="0"/>
           </a:p>
@@ -1789,7 +2041,7 @@
           <a:p>
             <a:r>
               <a:rPr lang="en-US" dirty="0"/>
-              <a:t>SMP2 Digital Transformation (September 2026): data-driven heat-cycle analysis identifies 25.6 h of recoverable furnace time (about 15 additional heats) by bringing slower heats to the median tap-to-tap time of 79 min. Quickest gains: blowing 7.0 min/heat and arcing 10.5 min/heat above the median in the slowest quarter of heats. Aligning Conarc3 to Conarc2 adds about 1.8 h. TAT reductions: coil tracing 160 min to 10 s; SCM commitment report 4 days to 3 min; quality KPI capture 3 days to 1 h; manpower distribution 5 h to 1 h.</a:t>
+              <a:t>Turnaround (by task): coil tracing 160 minutes to 10 seconds (99.9% less); commitment report 4 days to 3 minutes (99.9%); quality KPI capture 3 days to 1 hour (98.6%); manpower distribution 5 hours to 1 hour (80%). Output: +70 t/day blast-furnace production, stated by the project. Potential (project in progress): data-driven heat-cycle analysis for September 2026 identifies 25.6 h of recoverable furnace time (about 15 additional heats) by bringing slower heats to the median tap-to-tap time of 79 min; quickest gains are arcing (10.5 min/heat above median) and blowing (7 min/heat above median) in the slowest quarter of heats; aligning the two converters adds about 1.8 h. These are not multiplied up to a year.</a:t>
             </a:r>
             <a:endParaRPr lang="en-US" dirty="0"/>
           </a:p>
@@ -1813,94 +2065,6 @@
             <a:fld id="{F7021451-1387-4CA6-816F-3879F97B5CBC}" type="slidenum">
               <a:rPr lang="en-US"/>
               <a:t>4</a:t>
-            </a:fld>
-            <a:endParaRPr lang="en-US"/>
-          </a:p>
-        </p:txBody>
-      </p:sp>
-    </p:spTree>
-    <p:extLst>
-      <p:ext uri="{BB962C8B-B14F-4D97-AF65-F5344CB8AC3E}">
-        <p14:creationId xmlns:p14="http://schemas.microsoft.com/office/powerpoint/2010/main" val="1024086991"/>
-      </p:ext>
-    </p:extLst>
-  </p:cSld>
-  <p:clrMapOvr>
-    <a:masterClrMapping/>
-  </p:clrMapOvr>
-</p:notes>
-</file>
-
-<file path=ppt/notesSlides/notesSlide5.xml><?xml version="1.0" encoding="utf-8"?>
-<p:notes xmlns:a="http://schemas.openxmlformats.org/drawingml/2006/main" xmlns:r="http://schemas.openxmlformats.org/officeDocument/2006/relationships" xmlns:p="http://schemas.openxmlformats.org/presentationml/2006/main">
-  <p:cSld>
-    <p:spTree>
-      <p:nvGrpSpPr>
-        <p:cNvPr id="1" name=""/>
-        <p:cNvGrpSpPr/>
-        <p:nvPr/>
-      </p:nvGrpSpPr>
-      <p:grpSpPr>
-        <a:xfrm>
-          <a:off x="0" y="0"/>
-          <a:ext cx="0" cy="0"/>
-          <a:chOff x="0" y="0"/>
-          <a:chExt cx="0" cy="0"/>
-        </a:xfrm>
-      </p:grpSpPr>
-      <p:sp>
-        <p:nvSpPr>
-          <p:cNvPr id="2" name="Slide Image Placeholder 1"/>
-          <p:cNvSpPr>
-            <a:spLocks noGrp="1" noRot="1" noChangeAspect="1"/>
-          </p:cNvSpPr>
-          <p:nvPr>
-            <p:ph type="sldImg"/>
-          </p:nvPr>
-        </p:nvSpPr>
-        <p:spPr/>
-      </p:sp>
-      <p:sp>
-        <p:nvSpPr>
-          <p:cNvPr id="3" name="Notes Placeholder 2"/>
-          <p:cNvSpPr>
-            <a:spLocks noGrp="1"/>
-          </p:cNvSpPr>
-          <p:nvPr>
-            <p:ph type="body" idx="1"/>
-          </p:nvPr>
-        </p:nvSpPr>
-        <p:spPr/>
-        <p:txBody>
-          <a:bodyPr/>
-          <a:lstStyle/>
-          <a:p>
-            <a:r>
-              <a:rPr lang="en-US" dirty="0"/>
-              <a:t>Method files: database/tools/derive_ca_projects_deck.js (figures), ca_projects_extra.json (the two added projects), build_hod_benefits_deck.js (this deck).</a:t>
-            </a:r>
-            <a:endParaRPr lang="en-US" dirty="0"/>
-          </a:p>
-        </p:txBody>
-      </p:sp>
-      <p:sp>
-        <p:nvSpPr>
-          <p:cNvPr id="4" name="Slide Number Placeholder 3"/>
-          <p:cNvSpPr>
-            <a:spLocks noGrp="1"/>
-          </p:cNvSpPr>
-          <p:nvPr>
-            <p:ph type="sldNum" sz="quarter" idx="10"/>
-          </p:nvPr>
-        </p:nvSpPr>
-        <p:spPr/>
-        <p:txBody>
-          <a:bodyPr/>
-          <a:lstStyle/>
-          <a:p>
-            <a:fld id="{F7021451-1387-4CA6-816F-3879F97B5CBC}" type="slidenum">
-              <a:rPr lang="en-US"/>
-              <a:t>5</a:t>
             </a:fld>
             <a:endParaRPr lang="en-US"/>
           </a:p>
@@ -2488,7 +2652,7 @@
                 <a:ea typeface="Calibri" pitchFamily="34" charset="-122"/>
                 <a:cs typeface="Calibri" pitchFamily="34" charset="-120"/>
               </a:rPr>
-              <a:t>Benefits of 122 projects: money, FTE, TAT and productivity</a:t>
+              <a:t>Benefits at a glance: money, FTE, TAT and productivity</a:t>
             </a:r>
             <a:endParaRPr lang="en-US" sz="3000" dirty="0"/>
           </a:p>
@@ -2527,7 +2691,7 @@
                 <a:ea typeface="Calibri" pitchFamily="34" charset="-122"/>
                 <a:cs typeface="Calibri" pitchFamily="34" charset="-120"/>
               </a:rPr>
-              <a:t>Nov 2025 to 29 October 2026 and all in progress: 120 listed projects (54 live, 66 in progress) and 2 added by the owners (SMP2 Digital Transformation, Paradeep Ports).</a:t>
+              <a:t>Nov 2025 to 29 October 2026 and all in progress: 122 projects (54 live and 66 in progress from the project list, and 2 added by their owners).</a:t>
             </a:r>
             <a:endParaRPr lang="en-US" sz="1400" dirty="0"/>
           </a:p>
@@ -2567,7 +2731,7 @@
         <p:spPr>
           <a:xfrm>
             <a:off x="777240" y="1783080"/>
-            <a:ext cx="4005072" cy="274320"/>
+            <a:ext cx="2907792" cy="274320"/>
           </a:xfrm>
           <a:prstGeom prst="rect">
             <a:avLst/>
@@ -2599,13 +2763,13 @@
       </p:sp>
       <p:sp>
         <p:nvSpPr>
-          <p:cNvPr id="6" name="Money tag"/>
+          <p:cNvPr id="6" name="Money DERIVED tag"/>
           <p:cNvSpPr/>
           <p:nvPr/>
         </p:nvSpPr>
         <p:spPr>
           <a:xfrm>
-            <a:off x="4919472" y="1801368"/>
+            <a:off x="4965192" y="1801368"/>
             <a:ext cx="868680" cy="219456"/>
           </a:xfrm>
           <a:prstGeom prst="roundRect">
@@ -2716,7 +2880,7 @@
                 <a:ea typeface="Calibri" pitchFamily="34" charset="-122"/>
                 <a:cs typeface="Calibri" pitchFamily="34" charset="-120"/>
               </a:rPr>
-              <a:t>by the 54 live listed projects: built in-house for ₹21.0 Cr against ₹38.5 Cr from a software company (45% lower). All 120 listed: ₹34.7 Cr (44%).</a:t>
+              <a:t>by the 54 live projects: built in-house for ₹21.0 Cr against ₹38.5 Cr from a software company (45% lower). All 120 listed projects: ₹34.7 Cr (44%).</a:t>
             </a:r>
             <a:endParaRPr lang="en-US" sz="1400" dirty="0"/>
           </a:p>
@@ -2756,7 +2920,7 @@
         <p:spPr>
           <a:xfrm>
             <a:off x="6373368" y="1783080"/>
-            <a:ext cx="4005072" cy="274320"/>
+            <a:ext cx="2907792" cy="274320"/>
           </a:xfrm>
           <a:prstGeom prst="rect">
             <a:avLst/>
@@ -2788,13 +2952,13 @@
       </p:sp>
       <p:sp>
         <p:nvSpPr>
-          <p:cNvPr id="11" name="FTE tag"/>
+          <p:cNvPr id="11" name="FTE STATED tag"/>
           <p:cNvSpPr/>
           <p:nvPr/>
         </p:nvSpPr>
         <p:spPr>
           <a:xfrm>
-            <a:off x="10515600" y="1801368"/>
+            <a:off x="10561320" y="1801368"/>
             <a:ext cx="868680" cy="219456"/>
           </a:xfrm>
           <a:prstGeom prst="roundRect">
@@ -2905,7 +3069,7 @@
                 <a:ea typeface="Calibri" pitchFamily="34" charset="-122"/>
                 <a:cs typeface="Calibri" pitchFamily="34" charset="-120"/>
               </a:rPr>
-              <a:t>Paradeep Ports: 0.22 FTE (at 2,740 h). Slab identification 7 man-days down to 1 man-day; report preparation up to 99.2% less effort.</a:t>
+              <a:t>saved on one project (0.22 FTE at 2,740 h). Other tasks need up to 99.2% less effort: 7 man-days down to 1 man-day; 4-5 hours down to 1-2 minutes.</a:t>
             </a:r>
             <a:endParaRPr lang="en-US" sz="1400" dirty="0"/>
           </a:p>
@@ -2945,7 +3109,7 @@
         <p:spPr>
           <a:xfrm>
             <a:off x="777240" y="3840480"/>
-            <a:ext cx="4005072" cy="274320"/>
+            <a:ext cx="2907792" cy="274320"/>
           </a:xfrm>
           <a:prstGeom prst="rect">
             <a:avLst/>
@@ -2977,13 +3141,13 @@
       </p:sp>
       <p:sp>
         <p:nvSpPr>
-          <p:cNvPr id="16" name="TAT tag"/>
+          <p:cNvPr id="16" name="TAT STATED tag"/>
           <p:cNvSpPr/>
           <p:nvPr/>
         </p:nvSpPr>
         <p:spPr>
           <a:xfrm>
-            <a:off x="4919472" y="3858768"/>
+            <a:off x="4965192" y="3858768"/>
             <a:ext cx="868680" cy="219456"/>
           </a:xfrm>
           <a:prstGeom prst="roundRect">
@@ -3094,7 +3258,7 @@
                 <a:ea typeface="Calibri" pitchFamily="34" charset="-122"/>
                 <a:cs typeface="Calibri" pitchFamily="34" charset="-120"/>
               </a:rPr>
-              <a:t>Coil tracing 160 minutes to 10 seconds. SCM commitment report 4 days to 3 minutes. Quality KPI capture 3 days to 1 hour. Manpower distribution 5 hours to 1 hour.</a:t>
+              <a:t>Coil tracing 160 minutes to 10 seconds. Commitment report 4 days to 3 minutes. Quality KPI capture 3 days to 1 hour. Manpower distribution 5 hours to 1 hour.</a:t>
             </a:r>
             <a:endParaRPr lang="en-US" sz="1400" dirty="0"/>
           </a:p>
@@ -3134,7 +3298,7 @@
         <p:spPr>
           <a:xfrm>
             <a:off x="6373368" y="3840480"/>
-            <a:ext cx="4005072" cy="274320"/>
+            <a:ext cx="2907792" cy="274320"/>
           </a:xfrm>
           <a:prstGeom prst="rect">
             <a:avLst/>
@@ -3166,13 +3330,60 @@
       </p:sp>
       <p:sp>
         <p:nvSpPr>
-          <p:cNvPr id="21" name="Productivity tag"/>
+          <p:cNvPr id="21" name="Productivity POTENTIAL tag"/>
           <p:cNvSpPr/>
           <p:nvPr/>
         </p:nvSpPr>
         <p:spPr>
           <a:xfrm>
-            <a:off x="10515600" y="3858768"/>
+            <a:off x="10378440" y="3858768"/>
+            <a:ext cx="1051560" cy="219456"/>
+          </a:xfrm>
+          <a:prstGeom prst="roundRect">
+            <a:avLst>
+              <a:gd name="adj" fmla="val 20833"/>
+            </a:avLst>
+          </a:prstGeom>
+          <a:solidFill>
+            <a:srgbClr val="FFFFFF"/>
+          </a:solidFill>
+          <a:ln w="12700">
+            <a:solidFill>
+              <a:srgbClr val="0D5E72"/>
+            </a:solidFill>
+          </a:ln>
+        </p:spPr>
+        <p:txBody>
+          <a:bodyPr wrap="square" lIns="0" tIns="0" rIns="0" bIns="0" rtlCol="0" anchor="ctr"/>
+          <a:lstStyle/>
+          <a:p>
+            <a:pPr algn="ctr" indent="0" marL="0">
+              <a:buNone/>
+            </a:pPr>
+            <a:r>
+              <a:rPr lang="en-US" sz="1000" b="1" dirty="0">
+                <a:solidFill>
+                  <a:srgbClr val="0D5E72"/>
+                </a:solidFill>
+                <a:latin typeface="Calibri" pitchFamily="34" charset="0"/>
+                <a:ea typeface="Calibri" pitchFamily="34" charset="-122"/>
+                <a:cs typeface="Calibri" pitchFamily="34" charset="-120"/>
+              </a:rPr>
+              <a:t>POTENTIAL</a:t>
+            </a:r>
+            <a:endParaRPr lang="en-US" sz="1000" dirty="0"/>
+          </a:p>
+        </p:txBody>
+      </p:sp>
+      <p:sp>
+        <p:nvSpPr>
+          <p:cNvPr id="22" name="Productivity STATED tag"/>
+          <p:cNvSpPr/>
+          <p:nvPr/>
+        </p:nvSpPr>
+        <p:spPr>
+          <a:xfrm>
+            <a:off x="9436608" y="3858768"/>
             <a:ext cx="868680" cy="219456"/>
           </a:xfrm>
           <a:prstGeom prst="roundRect">
@@ -3213,7 +3424,7 @@
       </p:sp>
       <p:sp>
         <p:nvSpPr>
-          <p:cNvPr id="22" name="Productivity value"/>
+          <p:cNvPr id="23" name="Productivity value"/>
           <p:cNvSpPr txBox="1"/>
           <p:nvPr/>
         </p:nvSpPr>
@@ -3244,7 +3455,7 @@
                 <a:ea typeface="Calibri" pitchFamily="34" charset="-122"/>
                 <a:cs typeface="Calibri" pitchFamily="34" charset="-120"/>
               </a:rPr>
-              <a:t>~15 more heats a month</a:t>
+              <a:t>+70 t/day</a:t>
             </a:r>
             <a:endParaRPr lang="en-US" sz="3200" dirty="0"/>
           </a:p>
@@ -3252,7 +3463,7 @@
       </p:sp>
       <p:sp>
         <p:nvSpPr>
-          <p:cNvPr id="23" name="Productivity text"/>
+          <p:cNvPr id="24" name="Productivity text"/>
           <p:cNvSpPr txBox="1"/>
           <p:nvPr/>
         </p:nvSpPr>
@@ -3283,7 +3494,7 @@
                 <a:ea typeface="Calibri" pitchFamily="34" charset="-122"/>
                 <a:cs typeface="Calibri" pitchFamily="34" charset="-120"/>
               </a:rPr>
-              <a:t>SMP2: 25.6 h of furnace time recoverable in September 2026 (one month). C-MARVEL: +70 t/day blast-furnace production, ₹615 per ton lower cost. Stowage Plan: demurrage 30% lower.</a:t>
+              <a:t>blast-furnace production, and demurrage 30% lower. Potential, from a project still in progress: 25.6 h of furnace time (about 15 more heats) recoverable in a one-month analysis.</a:t>
             </a:r>
             <a:endParaRPr lang="en-US" sz="1400" dirty="0"/>
           </a:p>
@@ -3291,7 +3502,7 @@
       </p:sp>
       <p:sp>
         <p:nvSpPr>
-          <p:cNvPr id="24" name="Basis note"/>
+          <p:cNvPr id="25" name="Basis note"/>
           <p:cNvSpPr txBox="1"/>
           <p:nvPr/>
         </p:nvSpPr>
@@ -3322,7 +3533,7 @@
                 <a:ea typeface="Calibri" pitchFamily="34" charset="-122"/>
                 <a:cs typeface="Calibri" pitchFamily="34" charset="-120"/>
               </a:rPr>
-              <a:t>STATED = quoted from the project list or given by the project owner. DERIVED = worked out with the estimator's standard costing or the masters' rates. Money is external cost avoided, not cash released. The project cost of Paradeep Ports (₹17 L) is an investment, not a saving.</a:t>
+              <a:t>STATED = quoted from the project list or given by the project owner. DERIVED = worked out with the estimator's standard costing. POTENTIAL = a project still in progress: what it can give, not what it has given. Money is external cost avoided, not cash released. No rupee gain (Cal-2) is recorded in the list.</a:t>
             </a:r>
             <a:endParaRPr lang="en-US" sz="1100" dirty="0"/>
           </a:p>
@@ -3451,7 +3662,7 @@
         <p:spPr>
           <a:xfrm>
             <a:off x="548640" y="1234440"/>
-            <a:ext cx="6675120" cy="320040"/>
+            <a:ext cx="5577840" cy="320040"/>
           </a:xfrm>
           <a:prstGeom prst="rect">
             <a:avLst/>
@@ -3481,15 +3692,70 @@
           </a:p>
         </p:txBody>
       </p:sp>
-      <p:sp>
-        <p:nvSpPr>
-          <p:cNvPr id="4" name="DERIVED tag"/>
+      <p:graphicFrame>
+        <p:nvGraphicFramePr>
+          <p:cNvPr id="4" name="Cost chart" descr=""/>
+          <p:cNvGraphicFramePr/>
+          <p:nvPr/>
+        </p:nvGraphicFramePr>
+        <p:xfrm>
+          <a:off x="548640" y="1600200"/>
+          <a:ext cx="5760720" cy="3246120"/>
+        </p:xfrm>
+        <a:graphic xmlns:a="http://schemas.openxmlformats.org/drawingml/2006/main">
+          <a:graphicData uri="http://schemas.openxmlformats.org/drawingml/2006/chart">
+            <c:chart xmlns:c="http://schemas.openxmlformats.org/drawingml/2006/chart" r:id="rId1"/>
+          </a:graphicData>
+        </a:graphic>
+      </p:graphicFrame>
+      <p:sp>
+        <p:nvSpPr>
+          <p:cNvPr id="5" name="Avoided line"/>
+          <p:cNvSpPr txBox="1"/>
+          <p:nvPr/>
+        </p:nvSpPr>
+        <p:spPr>
+          <a:xfrm>
+            <a:off x="548640" y="4846320"/>
+            <a:ext cx="5760720" cy="274320"/>
+          </a:xfrm>
+          <a:prstGeom prst="rect">
+            <a:avLst/>
+          </a:prstGeom>
+          <a:noFill/>
+          <a:ln/>
+        </p:spPr>
+        <p:txBody>
+          <a:bodyPr wrap="square" lIns="0" tIns="0" rIns="0" bIns="0" rtlCol="0" anchor="ctr"/>
+          <a:lstStyle/>
+          <a:p>
+            <a:pPr indent="0" marL="0">
+              <a:buNone/>
+            </a:pPr>
+            <a:r>
+              <a:rPr lang="en-US" sz="1200" b="1" dirty="0">
+                <a:solidFill>
+                  <a:srgbClr val="1F7A45"/>
+                </a:solidFill>
+                <a:latin typeface="Calibri" pitchFamily="34" charset="0"/>
+                <a:ea typeface="Calibri" pitchFamily="34" charset="-122"/>
+                <a:cs typeface="Calibri" pitchFamily="34" charset="-120"/>
+              </a:rPr>
+              <a:t>Avoided:  live ₹17.5 Cr (45%)  ·  in progress ₹17.2 Cr (43%)  ·  all ₹34.7 Cr (44%)</a:t>
+            </a:r>
+            <a:endParaRPr lang="en-US" sz="1200" dirty="0"/>
+          </a:p>
+        </p:txBody>
+      </p:sp>
+      <p:sp>
+        <p:nvSpPr>
+          <p:cNvPr id="6" name="DERIVED tag"/>
           <p:cNvSpPr/>
           <p:nvPr/>
         </p:nvSpPr>
         <p:spPr>
           <a:xfrm>
-            <a:off x="6355080" y="1280160"/>
+            <a:off x="5440680" y="1280160"/>
             <a:ext cx="868680" cy="219456"/>
           </a:xfrm>
           <a:prstGeom prst="roundRect">
@@ -3528,32 +3794,71 @@
           </a:p>
         </p:txBody>
       </p:sp>
+      <p:sp>
+        <p:nvSpPr>
+          <p:cNvPr id="7" name="KPI heading"/>
+          <p:cNvSpPr txBox="1"/>
+          <p:nvPr/>
+        </p:nvSpPr>
+        <p:spPr>
+          <a:xfrm>
+            <a:off x="6583680" y="1234440"/>
+            <a:ext cx="5029200" cy="320040"/>
+          </a:xfrm>
+          <a:prstGeom prst="rect">
+            <a:avLst/>
+          </a:prstGeom>
+          <a:noFill/>
+          <a:ln/>
+        </p:spPr>
+        <p:txBody>
+          <a:bodyPr wrap="square" lIns="0" tIns="0" rIns="0" bIns="0" rtlCol="0" anchor="ctr"/>
+          <a:lstStyle/>
+          <a:p>
+            <a:pPr indent="0" marL="0">
+              <a:buNone/>
+            </a:pPr>
+            <a:r>
+              <a:rPr lang="en-US" sz="1500" b="1" dirty="0">
+                <a:solidFill>
+                  <a:srgbClr val="15222A"/>
+                </a:solidFill>
+                <a:latin typeface="Calibri" pitchFamily="34" charset="0"/>
+                <a:ea typeface="Calibri" pitchFamily="34" charset="-122"/>
+                <a:cs typeface="Calibri" pitchFamily="34" charset="-120"/>
+              </a:rPr>
+              <a:t>Cost avoided by business KPI, ₹ Cr (all 120 listed projects)</a:t>
+            </a:r>
+            <a:endParaRPr lang="en-US" sz="1500" dirty="0"/>
+          </a:p>
+        </p:txBody>
+      </p:sp>
       <p:graphicFrame>
         <p:nvGraphicFramePr>
-          <p:cNvPr id="5" name="Cost chart" descr=""/>
+          <p:cNvPr id="8" name="KPI chart" descr=""/>
           <p:cNvGraphicFramePr/>
           <p:nvPr/>
         </p:nvGraphicFramePr>
         <p:xfrm>
-          <a:off x="548640" y="1600200"/>
-          <a:ext cx="6675120" cy="3749040"/>
+          <a:off x="6583680" y="1600200"/>
+          <a:ext cx="5029200" cy="3520440"/>
         </p:xfrm>
         <a:graphic xmlns:a="http://schemas.openxmlformats.org/drawingml/2006/main">
           <a:graphicData uri="http://schemas.openxmlformats.org/drawingml/2006/chart">
-            <c:chart xmlns:c="http://schemas.openxmlformats.org/drawingml/2006/chart" r:id="rId1"/>
+            <c:chart xmlns:c="http://schemas.openxmlformats.org/drawingml/2006/chart" r:id="rId2"/>
           </a:graphicData>
         </a:graphic>
       </p:graphicFrame>
       <p:sp>
         <p:nvSpPr>
-          <p:cNvPr id="6" name="Avoided line"/>
+          <p:cNvPr id="9" name="Gains heading"/>
           <p:cNvSpPr txBox="1"/>
           <p:nvPr/>
         </p:nvSpPr>
         <p:spPr>
           <a:xfrm>
-            <a:off x="548640" y="5440680"/>
-            <a:ext cx="6675120" cy="274320"/>
+            <a:off x="548640" y="5212080"/>
+            <a:ext cx="3657600" cy="320040"/>
           </a:xfrm>
           <a:prstGeom prst="rect">
             <a:avLst/>
@@ -3569,7 +3874,54 @@
               <a:buNone/>
             </a:pPr>
             <a:r>
-              <a:rPr lang="en-US" sz="1200" b="1" dirty="0">
+              <a:rPr lang="en-US" sz="1500" b="1" dirty="0">
+                <a:solidFill>
+                  <a:srgbClr val="15222A"/>
+                </a:solidFill>
+                <a:latin typeface="Calibri" pitchFamily="34" charset="0"/>
+                <a:ea typeface="Calibri" pitchFamily="34" charset="-122"/>
+                <a:cs typeface="Calibri" pitchFamily="34" charset="-120"/>
+              </a:rPr>
+              <a:t>Stated money gains</a:t>
+            </a:r>
+            <a:endParaRPr lang="en-US" sz="1500" dirty="0"/>
+          </a:p>
+        </p:txBody>
+      </p:sp>
+      <p:sp>
+        <p:nvSpPr>
+          <p:cNvPr id="10" name="STATED tag"/>
+          <p:cNvSpPr/>
+          <p:nvPr/>
+        </p:nvSpPr>
+        <p:spPr>
+          <a:xfrm>
+            <a:off x="2468880" y="5257800"/>
+            <a:ext cx="868680" cy="219456"/>
+          </a:xfrm>
+          <a:prstGeom prst="roundRect">
+            <a:avLst>
+              <a:gd name="adj" fmla="val 20833"/>
+            </a:avLst>
+          </a:prstGeom>
+          <a:solidFill>
+            <a:srgbClr val="FFFFFF"/>
+          </a:solidFill>
+          <a:ln w="12700">
+            <a:solidFill>
+              <a:srgbClr val="1F7A45"/>
+            </a:solidFill>
+          </a:ln>
+        </p:spPr>
+        <p:txBody>
+          <a:bodyPr wrap="square" lIns="0" tIns="0" rIns="0" bIns="0" rtlCol="0" anchor="ctr"/>
+          <a:lstStyle/>
+          <a:p>
+            <a:pPr algn="ctr" indent="0" marL="0">
+              <a:buNone/>
+            </a:pPr>
+            <a:r>
+              <a:rPr lang="en-US" sz="1000" b="1" dirty="0">
                 <a:solidFill>
                   <a:srgbClr val="1F7A45"/>
                 </a:solidFill>
@@ -3577,22 +3929,22 @@
                 <a:ea typeface="Calibri" pitchFamily="34" charset="-122"/>
                 <a:cs typeface="Calibri" pitchFamily="34" charset="-120"/>
               </a:rPr>
-              <a:t>Avoided:  live ₹17.5 Cr (45%)   ·   in progress ₹17.2 Cr (43%)   ·   all ₹34.7 Cr (44%)</a:t>
+              <a:t>STATED</a:t>
             </a:r>
-            <a:endParaRPr lang="en-US" sz="1200" dirty="0"/>
-          </a:p>
-        </p:txBody>
-      </p:sp>
-      <p:sp>
-        <p:nvSpPr>
-          <p:cNvPr id="7" name="All card"/>
+            <a:endParaRPr lang="en-US" sz="1000" dirty="0"/>
+          </a:p>
+        </p:txBody>
+      </p:sp>
+      <p:sp>
+        <p:nvSpPr>
+          <p:cNvPr id="11" name="Cost chip"/>
           <p:cNvSpPr/>
           <p:nvPr/>
         </p:nvSpPr>
         <p:spPr>
           <a:xfrm>
-            <a:off x="7589520" y="1234440"/>
-            <a:ext cx="4023360" cy="1600200"/>
+            <a:off x="548640" y="5532120"/>
+            <a:ext cx="5440680" cy="777240"/>
           </a:xfrm>
           <a:prstGeom prst="rect">
             <a:avLst/>
@@ -3610,14 +3962,14 @@
       </p:sp>
       <p:sp>
         <p:nvSpPr>
-          <p:cNvPr id="8" name="All label"/>
+          <p:cNvPr id="12" name="Cost value"/>
           <p:cNvSpPr txBox="1"/>
           <p:nvPr/>
         </p:nvSpPr>
         <p:spPr>
           <a:xfrm>
-            <a:off x="7818120" y="1371600"/>
-            <a:ext cx="2560320" cy="274320"/>
+            <a:off x="685800" y="5577840"/>
+            <a:ext cx="1554480" cy="685800"/>
           </a:xfrm>
           <a:prstGeom prst="rect">
             <a:avLst/>
@@ -3633,93 +3985,7 @@
               <a:buNone/>
             </a:pPr>
             <a:r>
-              <a:rPr lang="en-US" sz="1200" b="1" spc="100" kern="0" dirty="0">
-                <a:solidFill>
-                  <a:srgbClr val="566872"/>
-                </a:solidFill>
-                <a:latin typeface="Calibri" pitchFamily="34" charset="0"/>
-                <a:ea typeface="Calibri" pitchFamily="34" charset="-122"/>
-                <a:cs typeface="Calibri" pitchFamily="34" charset="-120"/>
-              </a:rPr>
-              <a:t>ALL 120 LISTED PROJECTS</a:t>
-            </a:r>
-            <a:endParaRPr lang="en-US" sz="1200" dirty="0"/>
-          </a:p>
-        </p:txBody>
-      </p:sp>
-      <p:sp>
-        <p:nvSpPr>
-          <p:cNvPr id="9" name="All tag"/>
-          <p:cNvSpPr/>
-          <p:nvPr/>
-        </p:nvSpPr>
-        <p:spPr>
-          <a:xfrm>
-            <a:off x="10515600" y="1389888"/>
-            <a:ext cx="868680" cy="219456"/>
-          </a:xfrm>
-          <a:prstGeom prst="roundRect">
-            <a:avLst>
-              <a:gd name="adj" fmla="val 20833"/>
-            </a:avLst>
-          </a:prstGeom>
-          <a:solidFill>
-            <a:srgbClr val="FFFFFF"/>
-          </a:solidFill>
-          <a:ln w="12700">
-            <a:solidFill>
-              <a:srgbClr val="C98A00"/>
-            </a:solidFill>
-          </a:ln>
-        </p:spPr>
-        <p:txBody>
-          <a:bodyPr wrap="square" lIns="0" tIns="0" rIns="0" bIns="0" rtlCol="0" anchor="ctr"/>
-          <a:lstStyle/>
-          <a:p>
-            <a:pPr algn="ctr" indent="0" marL="0">
-              <a:buNone/>
-            </a:pPr>
-            <a:r>
-              <a:rPr lang="en-US" sz="1000" b="1" dirty="0">
-                <a:solidFill>
-                  <a:srgbClr val="8A5F00"/>
-                </a:solidFill>
-                <a:latin typeface="Calibri" pitchFamily="34" charset="0"/>
-                <a:ea typeface="Calibri" pitchFamily="34" charset="-122"/>
-                <a:cs typeface="Calibri" pitchFamily="34" charset="-120"/>
-              </a:rPr>
-              <a:t>DERIVED</a:t>
-            </a:r>
-            <a:endParaRPr lang="en-US" sz="1000" dirty="0"/>
-          </a:p>
-        </p:txBody>
-      </p:sp>
-      <p:sp>
-        <p:nvSpPr>
-          <p:cNvPr id="10" name="All value"/>
-          <p:cNvSpPr txBox="1"/>
-          <p:nvPr/>
-        </p:nvSpPr>
-        <p:spPr>
-          <a:xfrm>
-            <a:off x="7818120" y="1691640"/>
-            <a:ext cx="3566160" cy="594360"/>
-          </a:xfrm>
-          <a:prstGeom prst="rect">
-            <a:avLst/>
-          </a:prstGeom>
-          <a:noFill/>
-          <a:ln/>
-        </p:spPr>
-        <p:txBody>
-          <a:bodyPr wrap="square" lIns="0" tIns="0" rIns="0" bIns="0" rtlCol="0" anchor="ctr"/>
-          <a:lstStyle/>
-          <a:p>
-            <a:pPr indent="0" marL="0">
-              <a:buNone/>
-            </a:pPr>
-            <a:r>
-              <a:rPr lang="en-US" sz="3200" b="1" dirty="0">
+              <a:rPr lang="en-US" sz="2000" b="1" dirty="0">
                 <a:solidFill>
                   <a:srgbClr val="0D5E72"/>
                 </a:solidFill>
@@ -3727,125 +3993,22 @@
                 <a:ea typeface="Calibri" pitchFamily="34" charset="-122"/>
                 <a:cs typeface="Calibri" pitchFamily="34" charset="-120"/>
               </a:rPr>
-              <a:t>₹34.7 Cr</a:t>
+              <a:t>₹615 / ton</a:t>
             </a:r>
-            <a:endParaRPr lang="en-US" sz="3200" dirty="0"/>
-          </a:p>
-        </p:txBody>
-      </p:sp>
-      <p:sp>
-        <p:nvSpPr>
-          <p:cNvPr id="11" name="All text"/>
+            <a:endParaRPr lang="en-US" sz="2000" dirty="0"/>
+          </a:p>
+        </p:txBody>
+      </p:sp>
+      <p:sp>
+        <p:nvSpPr>
+          <p:cNvPr id="13" name="Cost text"/>
           <p:cNvSpPr txBox="1"/>
           <p:nvPr/>
         </p:nvSpPr>
         <p:spPr>
           <a:xfrm>
-            <a:off x="7818120" y="2331720"/>
-            <a:ext cx="3566160" cy="411480"/>
-          </a:xfrm>
-          <a:prstGeom prst="rect">
-            <a:avLst/>
-          </a:prstGeom>
-          <a:noFill/>
-          <a:ln/>
-        </p:spPr>
-        <p:txBody>
-          <a:bodyPr wrap="square" lIns="0" tIns="0" rIns="0" bIns="0" rtlCol="0" anchor="t"/>
-          <a:lstStyle/>
-          <a:p>
-            <a:pPr indent="0" marL="0">
-              <a:buNone/>
-            </a:pPr>
-            <a:r>
-              <a:rPr lang="en-US" sz="1400" dirty="0">
-                <a:solidFill>
-                  <a:srgbClr val="15222A"/>
-                </a:solidFill>
-                <a:latin typeface="Calibri" pitchFamily="34" charset="0"/>
-                <a:ea typeface="Calibri" pitchFamily="34" charset="-122"/>
-                <a:cs typeface="Calibri" pitchFamily="34" charset="-120"/>
-              </a:rPr>
-              <a:t>44% below a software company; 13,783 person-days either way.</a:t>
-            </a:r>
-            <a:endParaRPr lang="en-US" sz="1400" dirty="0"/>
-          </a:p>
-        </p:txBody>
-      </p:sp>
-      <p:sp>
-        <p:nvSpPr>
-          <p:cNvPr id="12" name="Paradeep box"/>
-          <p:cNvSpPr/>
-          <p:nvPr/>
-        </p:nvSpPr>
-        <p:spPr>
-          <a:xfrm>
-            <a:off x="7589520" y="3017520"/>
-            <a:ext cx="4023360" cy="2697480"/>
-          </a:xfrm>
-          <a:prstGeom prst="rect">
-            <a:avLst/>
-          </a:prstGeom>
-          <a:solidFill>
-            <a:srgbClr val="FFF8E6"/>
-          </a:solidFill>
-          <a:ln w="12700">
-            <a:solidFill>
-              <a:srgbClr val="E4B33E"/>
-            </a:solidFill>
-            <a:prstDash val="solid"/>
-          </a:ln>
-        </p:spPr>
-      </p:sp>
-      <p:sp>
-        <p:nvSpPr>
-          <p:cNvPr id="13" name="Paradeep heading"/>
-          <p:cNvSpPr txBox="1"/>
-          <p:nvPr/>
-        </p:nvSpPr>
-        <p:spPr>
-          <a:xfrm>
-            <a:off x="7772400" y="3108960"/>
-            <a:ext cx="3657600" cy="292608"/>
-          </a:xfrm>
-          <a:prstGeom prst="rect">
-            <a:avLst/>
-          </a:prstGeom>
-          <a:noFill/>
-          <a:ln/>
-        </p:spPr>
-        <p:txBody>
-          <a:bodyPr wrap="square" lIns="0" tIns="0" rIns="0" bIns="0" rtlCol="0" anchor="ctr"/>
-          <a:lstStyle/>
-          <a:p>
-            <a:pPr indent="0" marL="0">
-              <a:buNone/>
-            </a:pPr>
-            <a:r>
-              <a:rPr lang="en-US" sz="1400" b="1" dirty="0">
-                <a:solidFill>
-                  <a:srgbClr val="15222A"/>
-                </a:solidFill>
-                <a:latin typeface="Calibri" pitchFamily="34" charset="0"/>
-                <a:ea typeface="Calibri" pitchFamily="34" charset="-122"/>
-                <a:cs typeface="Calibri" pitchFamily="34" charset="-120"/>
-              </a:rPr>
-              <a:t>Added project: Paradeep Ports</a:t>
-            </a:r>
-            <a:endParaRPr lang="en-US" sz="1400" dirty="0"/>
-          </a:p>
-        </p:txBody>
-      </p:sp>
-      <p:sp>
-        <p:nvSpPr>
-          <p:cNvPr id="14" name="Paradeep Project cost"/>
-          <p:cNvSpPr txBox="1"/>
-          <p:nvPr/>
-        </p:nvSpPr>
-        <p:spPr>
-          <a:xfrm>
-            <a:off x="7772400" y="3456432"/>
-            <a:ext cx="2331720" cy="457200"/>
+            <a:off x="2286000" y="5577840"/>
+            <a:ext cx="3566160" cy="685800"/>
           </a:xfrm>
           <a:prstGeom prst="rect">
             <a:avLst/>
@@ -3869,7 +4032,7 @@
                 <a:ea typeface="Calibri" pitchFamily="34" charset="-122"/>
                 <a:cs typeface="Calibri" pitchFamily="34" charset="-120"/>
               </a:rPr>
-              <a:t>Project cost, the investment (STATED)</a:t>
+              <a:t>lower cost of production, Hazira (C-MARVEL)</a:t>
             </a:r>
             <a:endParaRPr lang="en-US" sz="1200" dirty="0"/>
           </a:p>
@@ -3877,14 +4040,39 @@
       </p:sp>
       <p:sp>
         <p:nvSpPr>
-          <p:cNvPr id="15" name="Paradeep value Project "/>
+          <p:cNvPr id="14" name="Demurrage chip"/>
+          <p:cNvSpPr/>
+          <p:nvPr/>
+        </p:nvSpPr>
+        <p:spPr>
+          <a:xfrm>
+            <a:off x="6172200" y="5532120"/>
+            <a:ext cx="5440680" cy="777240"/>
+          </a:xfrm>
+          <a:prstGeom prst="rect">
+            <a:avLst/>
+          </a:prstGeom>
+          <a:solidFill>
+            <a:srgbClr val="EEF3F5"/>
+          </a:solidFill>
+          <a:ln w="9525">
+            <a:solidFill>
+              <a:srgbClr val="D3DBE0"/>
+            </a:solidFill>
+            <a:prstDash val="solid"/>
+          </a:ln>
+        </p:spPr>
+      </p:sp>
+      <p:sp>
+        <p:nvSpPr>
+          <p:cNvPr id="15" name="Demurrage value"/>
           <p:cNvSpPr txBox="1"/>
           <p:nvPr/>
         </p:nvSpPr>
         <p:spPr>
           <a:xfrm>
-            <a:off x="10058400" y="3456432"/>
-            <a:ext cx="1463040" cy="457200"/>
+            <a:off x="6309360" y="5577840"/>
+            <a:ext cx="1554480" cy="685800"/>
           </a:xfrm>
           <a:prstGeom prst="rect">
             <a:avLst/>
@@ -3896,11 +4084,11 @@
           <a:bodyPr wrap="square" lIns="0" tIns="0" rIns="0" bIns="0" rtlCol="0" anchor="ctr"/>
           <a:lstStyle/>
           <a:p>
-            <a:pPr algn="r" indent="0" marL="0">
+            <a:pPr indent="0" marL="0">
               <a:buNone/>
             </a:pPr>
             <a:r>
-              <a:rPr lang="en-US" sz="1400" b="1" dirty="0">
+              <a:rPr lang="en-US" sz="2000" b="1" dirty="0">
                 <a:solidFill>
                   <a:srgbClr val="0D5E72"/>
                 </a:solidFill>
@@ -3908,22 +4096,22 @@
                 <a:ea typeface="Calibri" pitchFamily="34" charset="-122"/>
                 <a:cs typeface="Calibri" pitchFamily="34" charset="-120"/>
               </a:rPr>
-              <a:t>₹17.0 L</a:t>
+              <a:t>30% lower</a:t>
             </a:r>
-            <a:endParaRPr lang="en-US" sz="1400" dirty="0"/>
-          </a:p>
-        </p:txBody>
-      </p:sp>
-      <p:sp>
-        <p:nvSpPr>
-          <p:cNvPr id="16" name="Paradeep Time saved: "/>
+            <a:endParaRPr lang="en-US" sz="2000" dirty="0"/>
+          </a:p>
+        </p:txBody>
+      </p:sp>
+      <p:sp>
+        <p:nvSpPr>
+          <p:cNvPr id="16" name="Demurrage text"/>
           <p:cNvSpPr txBox="1"/>
           <p:nvPr/>
         </p:nvSpPr>
         <p:spPr>
           <a:xfrm>
-            <a:off x="7772400" y="3913632"/>
-            <a:ext cx="2331720" cy="457200"/>
+            <a:off x="7909560" y="5577840"/>
+            <a:ext cx="3566160" cy="685800"/>
           </a:xfrm>
           <a:prstGeom prst="rect">
             <a:avLst/>
@@ -3947,282 +4135,9 @@
                 <a:ea typeface="Calibri" pitchFamily="34" charset="-122"/>
                 <a:cs typeface="Calibri" pitchFamily="34" charset="-120"/>
               </a:rPr>
-              <a:t>Time saved: 600 man-hours = 75 man-days a year (STATED)</a:t>
+              <a:t>demurrage, with real-time visibility (Stowage Plan)</a:t>
             </a:r>
             <a:endParaRPr lang="en-US" sz="1200" dirty="0"/>
-          </a:p>
-        </p:txBody>
-      </p:sp>
-      <p:sp>
-        <p:nvSpPr>
-          <p:cNvPr id="17" name="Paradeep value Time sav"/>
-          <p:cNvSpPr txBox="1"/>
-          <p:nvPr/>
-        </p:nvSpPr>
-        <p:spPr>
-          <a:xfrm>
-            <a:off x="10058400" y="3913632"/>
-            <a:ext cx="1463040" cy="457200"/>
-          </a:xfrm>
-          <a:prstGeom prst="rect">
-            <a:avLst/>
-          </a:prstGeom>
-          <a:noFill/>
-          <a:ln/>
-        </p:spPr>
-        <p:txBody>
-          <a:bodyPr wrap="square" lIns="0" tIns="0" rIns="0" bIns="0" rtlCol="0" anchor="ctr"/>
-          <a:lstStyle/>
-          <a:p>
-            <a:pPr algn="r" indent="0" marL="0">
-              <a:buNone/>
-            </a:pPr>
-            <a:r>
-              <a:rPr lang="en-US" sz="1400" b="1" dirty="0">
-                <a:solidFill>
-                  <a:srgbClr val="0D5E72"/>
-                </a:solidFill>
-                <a:latin typeface="Calibri" pitchFamily="34" charset="0"/>
-                <a:ea typeface="Calibri" pitchFamily="34" charset="-122"/>
-                <a:cs typeface="Calibri" pitchFamily="34" charset="-120"/>
-              </a:rPr>
-              <a:t>75 days</a:t>
-            </a:r>
-            <a:endParaRPr lang="en-US" sz="1400" dirty="0"/>
-          </a:p>
-        </p:txBody>
-      </p:sp>
-      <p:sp>
-        <p:nvSpPr>
-          <p:cNvPr id="18" name="Paradeep Worth at the"/>
-          <p:cNvSpPr txBox="1"/>
-          <p:nvPr/>
-        </p:nvSpPr>
-        <p:spPr>
-          <a:xfrm>
-            <a:off x="7772400" y="4370832"/>
-            <a:ext cx="2331720" cy="457200"/>
-          </a:xfrm>
-          <a:prstGeom prst="rect">
-            <a:avLst/>
-          </a:prstGeom>
-          <a:noFill/>
-          <a:ln/>
-        </p:spPr>
-        <p:txBody>
-          <a:bodyPr wrap="square" lIns="0" tIns="0" rIns="0" bIns="0" rtlCol="0" anchor="ctr"/>
-          <a:lstStyle/>
-          <a:p>
-            <a:pPr indent="0" marL="0">
-              <a:buNone/>
-            </a:pPr>
-            <a:r>
-              <a:rPr lang="en-US" sz="1200" dirty="0">
-                <a:solidFill>
-                  <a:srgbClr val="15222A"/>
-                </a:solidFill>
-                <a:latin typeface="Calibri" pitchFamily="34" charset="0"/>
-                <a:ea typeface="Calibri" pitchFamily="34" charset="-122"/>
-                <a:cs typeface="Calibri" pitchFamily="34" charset="-120"/>
-              </a:rPr>
-              <a:t>Worth at the ₹6,000 Mid man-day rate (DERIVED)</a:t>
-            </a:r>
-            <a:endParaRPr lang="en-US" sz="1200" dirty="0"/>
-          </a:p>
-        </p:txBody>
-      </p:sp>
-      <p:sp>
-        <p:nvSpPr>
-          <p:cNvPr id="19" name="Paradeep value Worth at"/>
-          <p:cNvSpPr txBox="1"/>
-          <p:nvPr/>
-        </p:nvSpPr>
-        <p:spPr>
-          <a:xfrm>
-            <a:off x="10058400" y="4370832"/>
-            <a:ext cx="1463040" cy="457200"/>
-          </a:xfrm>
-          <a:prstGeom prst="rect">
-            <a:avLst/>
-          </a:prstGeom>
-          <a:noFill/>
-          <a:ln/>
-        </p:spPr>
-        <p:txBody>
-          <a:bodyPr wrap="square" lIns="0" tIns="0" rIns="0" bIns="0" rtlCol="0" anchor="ctr"/>
-          <a:lstStyle/>
-          <a:p>
-            <a:pPr algn="r" indent="0" marL="0">
-              <a:buNone/>
-            </a:pPr>
-            <a:r>
-              <a:rPr lang="en-US" sz="1400" b="1" dirty="0">
-                <a:solidFill>
-                  <a:srgbClr val="0D5E72"/>
-                </a:solidFill>
-                <a:latin typeface="Calibri" pitchFamily="34" charset="0"/>
-                <a:ea typeface="Calibri" pitchFamily="34" charset="-122"/>
-                <a:cs typeface="Calibri" pitchFamily="34" charset="-120"/>
-              </a:rPr>
-              <a:t>≈ ₹4.5 L a year</a:t>
-            </a:r>
-            <a:endParaRPr lang="en-US" sz="1400" dirty="0"/>
-          </a:p>
-        </p:txBody>
-      </p:sp>
-      <p:sp>
-        <p:nvSpPr>
-          <p:cNvPr id="20" name="Paradeep Simple payba"/>
-          <p:cNvSpPr txBox="1"/>
-          <p:nvPr/>
-        </p:nvSpPr>
-        <p:spPr>
-          <a:xfrm>
-            <a:off x="7772400" y="4828032"/>
-            <a:ext cx="2331720" cy="457200"/>
-          </a:xfrm>
-          <a:prstGeom prst="rect">
-            <a:avLst/>
-          </a:prstGeom>
-          <a:noFill/>
-          <a:ln/>
-        </p:spPr>
-        <p:txBody>
-          <a:bodyPr wrap="square" lIns="0" tIns="0" rIns="0" bIns="0" rtlCol="0" anchor="ctr"/>
-          <a:lstStyle/>
-          <a:p>
-            <a:pPr indent="0" marL="0">
-              <a:buNone/>
-            </a:pPr>
-            <a:r>
-              <a:rPr lang="en-US" sz="1200" dirty="0">
-                <a:solidFill>
-                  <a:srgbClr val="15222A"/>
-                </a:solidFill>
-                <a:latin typeface="Calibri" pitchFamily="34" charset="0"/>
-                <a:ea typeface="Calibri" pitchFamily="34" charset="-122"/>
-                <a:cs typeface="Calibri" pitchFamily="34" charset="-120"/>
-              </a:rPr>
-              <a:t>Simple payback (DERIVED)</a:t>
-            </a:r>
-            <a:endParaRPr lang="en-US" sz="1200" dirty="0"/>
-          </a:p>
-        </p:txBody>
-      </p:sp>
-      <p:sp>
-        <p:nvSpPr>
-          <p:cNvPr id="21" name="Paradeep value Simple p"/>
-          <p:cNvSpPr txBox="1"/>
-          <p:nvPr/>
-        </p:nvSpPr>
-        <p:spPr>
-          <a:xfrm>
-            <a:off x="10058400" y="4828032"/>
-            <a:ext cx="1463040" cy="457200"/>
-          </a:xfrm>
-          <a:prstGeom prst="rect">
-            <a:avLst/>
-          </a:prstGeom>
-          <a:noFill/>
-          <a:ln/>
-        </p:spPr>
-        <p:txBody>
-          <a:bodyPr wrap="square" lIns="0" tIns="0" rIns="0" bIns="0" rtlCol="0" anchor="ctr"/>
-          <a:lstStyle/>
-          <a:p>
-            <a:pPr algn="r" indent="0" marL="0">
-              <a:buNone/>
-            </a:pPr>
-            <a:r>
-              <a:rPr lang="en-US" sz="1400" b="1" dirty="0">
-                <a:solidFill>
-                  <a:srgbClr val="0D5E72"/>
-                </a:solidFill>
-                <a:latin typeface="Calibri" pitchFamily="34" charset="0"/>
-                <a:ea typeface="Calibri" pitchFamily="34" charset="-122"/>
-                <a:cs typeface="Calibri" pitchFamily="34" charset="-120"/>
-              </a:rPr>
-              <a:t>≈ 3.8 years</a:t>
-            </a:r>
-            <a:endParaRPr lang="en-US" sz="1400" dirty="0"/>
-          </a:p>
-        </p:txBody>
-      </p:sp>
-      <p:sp>
-        <p:nvSpPr>
-          <p:cNvPr id="22" name="Paradeep caution"/>
-          <p:cNvSpPr txBox="1"/>
-          <p:nvPr/>
-        </p:nvSpPr>
-        <p:spPr>
-          <a:xfrm>
-            <a:off x="7772400" y="5321808"/>
-            <a:ext cx="3657600" cy="274320"/>
-          </a:xfrm>
-          <a:prstGeom prst="rect">
-            <a:avLst/>
-          </a:prstGeom>
-          <a:noFill/>
-          <a:ln/>
-        </p:spPr>
-        <p:txBody>
-          <a:bodyPr wrap="square" lIns="0" tIns="0" rIns="0" bIns="0" rtlCol="0" anchor="ctr"/>
-          <a:lstStyle/>
-          <a:p>
-            <a:pPr indent="0" marL="0">
-              <a:buNone/>
-            </a:pPr>
-            <a:r>
-              <a:rPr lang="en-US" sz="1100" i="1" dirty="0">
-                <a:solidFill>
-                  <a:srgbClr val="566872"/>
-                </a:solidFill>
-                <a:latin typeface="Calibri" pitchFamily="34" charset="0"/>
-                <a:ea typeface="Calibri" pitchFamily="34" charset="-122"/>
-                <a:cs typeface="Calibri" pitchFamily="34" charset="-120"/>
-              </a:rPr>
-              <a:t>The ₹17 L is what the project cost, not a saving.</a:t>
-            </a:r>
-            <a:endParaRPr lang="en-US" sz="1100" dirty="0"/>
-          </a:p>
-        </p:txBody>
-      </p:sp>
-      <p:sp>
-        <p:nvSpPr>
-          <p:cNvPr id="23" name="Basis note"/>
-          <p:cNvSpPr txBox="1"/>
-          <p:nvPr/>
-        </p:nvSpPr>
-        <p:spPr>
-          <a:xfrm>
-            <a:off x="548640" y="5897880"/>
-            <a:ext cx="11064240" cy="502920"/>
-          </a:xfrm>
-          <a:prstGeom prst="rect">
-            <a:avLst/>
-          </a:prstGeom>
-          <a:noFill/>
-          <a:ln/>
-        </p:spPr>
-        <p:txBody>
-          <a:bodyPr wrap="square" lIns="0" tIns="0" rIns="0" bIns="0" rtlCol="0" anchor="t"/>
-          <a:lstStyle/>
-          <a:p>
-            <a:pPr indent="0" marL="0">
-              <a:buNone/>
-            </a:pPr>
-            <a:r>
-              <a:rPr lang="en-US" sz="1100" dirty="0">
-                <a:solidFill>
-                  <a:srgbClr val="566872"/>
-                </a:solidFill>
-                <a:latin typeface="Calibri" pitchFamily="34" charset="0"/>
-                <a:ea typeface="Calibri" pitchFamily="34" charset="-122"/>
-                <a:cs typeface="Calibri" pitchFamily="34" charset="-120"/>
-              </a:rPr>
-              <a:t>Derived, not recorded: the project list holds no costs, so each listed project is costed with the estimator's standard assumptions (one person, Senior for AI / ML / vision models else Mid; working days between its dates, 90 if a date is missing; default masters; 3 years). Same effort on both sides: the difference is in-house rates, loadings and mark-up against a software company's. SMP2 gave no cost and is not in these totals.</a:t>
-            </a:r>
-            <a:endParaRPr lang="en-US" sz="1100" dirty="0"/>
           </a:p>
         </p:txBody>
       </p:sp>
@@ -4334,7 +4249,7 @@
                 <a:ea typeface="Calibri" pitchFamily="34" charset="-122"/>
                 <a:cs typeface="Calibri" pitchFamily="34" charset="-120"/>
               </a:rPr>
-              <a:t>FTE and effort: working time saved</a:t>
+              <a:t>FTE: working time saved</a:t>
             </a:r>
             <a:endParaRPr lang="en-US" sz="3000" dirty="0"/>
           </a:p>
@@ -4349,7 +4264,7 @@
         <p:spPr>
           <a:xfrm>
             <a:off x="548640" y="1234440"/>
-            <a:ext cx="6766560" cy="320040"/>
+            <a:ext cx="4754880" cy="320040"/>
           </a:xfrm>
           <a:prstGeom prst="rect">
             <a:avLst/>
@@ -4884,7 +4799,7 @@
                           <a:ea typeface="Calibri" pitchFamily="34" charset="-122"/>
                           <a:cs typeface="Calibri" pitchFamily="34" charset="-120"/>
                         </a:rPr>
-                        <a:t>Paradeep Ports</a:t>
+                        <a:t>Port logistics</a:t>
                       </a:r>
                       <a:endParaRPr lang="en-US" sz="1200" dirty="0">
                         <a:latin typeface="Calibri" charset="0"/>
@@ -4949,7 +4864,7 @@
                           <a:ea typeface="Calibri" pitchFamily="34" charset="-122"/>
                           <a:cs typeface="Calibri" pitchFamily="34" charset="-120"/>
                         </a:rPr>
-                        <a:t>Manual assessment per shipment</a:t>
+                        <a:t>Shipment assessment</a:t>
                       </a:r>
                       <a:endParaRPr lang="en-US" sz="1200" dirty="0">
                         <a:latin typeface="Calibri" charset="0"/>
@@ -6093,7 +6008,7 @@
         </p:nvGraphicFramePr>
         <p:xfrm>
           <a:off x="548640" y="3977640"/>
-          <a:ext cx="6858000" cy="1828800"/>
+          <a:ext cx="6949440" cy="1828800"/>
         </p:xfrm>
         <a:graphic xmlns:a="http://schemas.openxmlformats.org/drawingml/2006/main">
           <a:graphicData uri="http://schemas.openxmlformats.org/drawingml/2006/chart">
@@ -6103,7 +6018,7 @@
       </p:graphicFrame>
       <p:sp>
         <p:nvSpPr>
-          <p:cNvPr id="8" name="Paradeep card"/>
+          <p:cNvPr id="8" name="Hours card"/>
           <p:cNvSpPr/>
           <p:nvPr/>
         </p:nvSpPr>
@@ -6128,14 +6043,14 @@
       </p:sp>
       <p:sp>
         <p:nvSpPr>
-          <p:cNvPr id="9" name="Paradeep label"/>
+          <p:cNvPr id="9" name="Hours label"/>
           <p:cNvSpPr txBox="1"/>
           <p:nvPr/>
         </p:nvSpPr>
         <p:spPr>
           <a:xfrm>
             <a:off x="8001000" y="1371600"/>
-            <a:ext cx="2377440" cy="274320"/>
+            <a:ext cx="1280160" cy="274320"/>
           </a:xfrm>
           <a:prstGeom prst="rect">
             <a:avLst/>
@@ -6159,7 +6074,7 @@
                 <a:ea typeface="Calibri" pitchFamily="34" charset="-122"/>
                 <a:cs typeface="Calibri" pitchFamily="34" charset="-120"/>
               </a:rPr>
-              <a:t>PARADEEP PORTS, PER YEAR</a:t>
+              <a:t>TIME SAVED ON ONE PROJECT</a:t>
             </a:r>
             <a:endParaRPr lang="en-US" sz="1200" dirty="0"/>
           </a:p>
@@ -6167,13 +6082,13 @@
       </p:sp>
       <p:sp>
         <p:nvSpPr>
-          <p:cNvPr id="10" name="Paradeep tag"/>
+          <p:cNvPr id="10" name="Hours STATED tag"/>
           <p:cNvSpPr/>
           <p:nvPr/>
         </p:nvSpPr>
         <p:spPr>
           <a:xfrm>
-            <a:off x="10515600" y="1389888"/>
+            <a:off x="10561320" y="1389888"/>
             <a:ext cx="868680" cy="219456"/>
           </a:xfrm>
           <a:prstGeom prst="roundRect">
@@ -6214,7 +6129,7 @@
       </p:sp>
       <p:sp>
         <p:nvSpPr>
-          <p:cNvPr id="11" name="Paradeep value"/>
+          <p:cNvPr id="11" name="Hours value"/>
           <p:cNvSpPr txBox="1"/>
           <p:nvPr/>
         </p:nvSpPr>
@@ -6253,7 +6168,7 @@
       </p:sp>
       <p:sp>
         <p:nvSpPr>
-          <p:cNvPr id="12" name="Paradeep text"/>
+          <p:cNvPr id="12" name="Hours text"/>
           <p:cNvSpPr txBox="1"/>
           <p:nvPr/>
         </p:nvSpPr>
@@ -6284,7 +6199,7 @@
                 <a:ea typeface="Calibri" pitchFamily="34" charset="-122"/>
                 <a:cs typeface="Calibri" pitchFamily="34" charset="-120"/>
               </a:rPr>
-              <a:t>36,000 minutes saved a year. 600 h = 0.22 FTE at 2,740 h per FTE.</a:t>
+              <a:t>36,000 minutes a year. 600 h = 0.22 FTE at 2,740 h per FTE.</a:t>
             </a:r>
             <a:endParaRPr lang="en-US" sz="1400" dirty="0"/>
           </a:p>
@@ -6292,14 +6207,14 @@
       </p:sp>
       <p:sp>
         <p:nvSpPr>
-          <p:cNvPr id="13" name="Reading card"/>
+          <p:cNvPr id="13" name="Effort card"/>
           <p:cNvSpPr/>
           <p:nvPr/>
         </p:nvSpPr>
         <p:spPr>
           <a:xfrm>
-            <a:off x="7772400" y="3657600"/>
-            <a:ext cx="3840480" cy="2103120"/>
+            <a:off x="7772400" y="3611880"/>
+            <a:ext cx="3840480" cy="2194560"/>
           </a:xfrm>
           <a:prstGeom prst="rect">
             <a:avLst/>
@@ -6317,14 +6232,14 @@
       </p:sp>
       <p:sp>
         <p:nvSpPr>
-          <p:cNvPr id="14" name="Reading text"/>
+          <p:cNvPr id="14" name="Effort label"/>
           <p:cNvSpPr txBox="1"/>
           <p:nvPr/>
         </p:nvSpPr>
         <p:spPr>
           <a:xfrm>
-            <a:off x="7909560" y="3749040"/>
-            <a:ext cx="3566160" cy="1920240"/>
+            <a:off x="8001000" y="3749040"/>
+            <a:ext cx="1280160" cy="274320"/>
           </a:xfrm>
           <a:prstGeom prst="rect">
             <a:avLst/>
@@ -6333,17 +6248,139 @@
           <a:ln/>
         </p:spPr>
         <p:txBody>
-          <a:bodyPr wrap="square" lIns="0" tIns="0" rIns="0" bIns="0" rtlCol="0" anchor="t"/>
+          <a:bodyPr wrap="square" lIns="0" tIns="0" rIns="0" bIns="0" rtlCol="0" anchor="ctr"/>
           <a:lstStyle/>
           <a:p>
             <a:pPr indent="0" marL="0">
-              <a:spcAft>
-                <a:spcPts val="400"/>
-              </a:spcAft>
               <a:buNone/>
             </a:pPr>
             <a:r>
-              <a:rPr lang="en-US" sz="1200" b="1" dirty="0">
+              <a:rPr lang="en-US" sz="1200" b="1" spc="100" kern="0" dirty="0">
+                <a:solidFill>
+                  <a:srgbClr val="566872"/>
+                </a:solidFill>
+                <a:latin typeface="Calibri" pitchFamily="34" charset="0"/>
+                <a:ea typeface="Calibri" pitchFamily="34" charset="-122"/>
+                <a:cs typeface="Calibri" pitchFamily="34" charset="-120"/>
+              </a:rPr>
+              <a:t>IN-HOUSE BUILD EFFORT</a:t>
+            </a:r>
+            <a:endParaRPr lang="en-US" sz="1200" dirty="0"/>
+          </a:p>
+        </p:txBody>
+      </p:sp>
+      <p:sp>
+        <p:nvSpPr>
+          <p:cNvPr id="15" name="Effort DERIVED tag"/>
+          <p:cNvSpPr/>
+          <p:nvPr/>
+        </p:nvSpPr>
+        <p:spPr>
+          <a:xfrm>
+            <a:off x="10561320" y="3767328"/>
+            <a:ext cx="868680" cy="219456"/>
+          </a:xfrm>
+          <a:prstGeom prst="roundRect">
+            <a:avLst>
+              <a:gd name="adj" fmla="val 20833"/>
+            </a:avLst>
+          </a:prstGeom>
+          <a:solidFill>
+            <a:srgbClr val="FFFFFF"/>
+          </a:solidFill>
+          <a:ln w="12700">
+            <a:solidFill>
+              <a:srgbClr val="C98A00"/>
+            </a:solidFill>
+          </a:ln>
+        </p:spPr>
+        <p:txBody>
+          <a:bodyPr wrap="square" lIns="0" tIns="0" rIns="0" bIns="0" rtlCol="0" anchor="ctr"/>
+          <a:lstStyle/>
+          <a:p>
+            <a:pPr algn="ctr" indent="0" marL="0">
+              <a:buNone/>
+            </a:pPr>
+            <a:r>
+              <a:rPr lang="en-US" sz="1000" b="1" dirty="0">
+                <a:solidFill>
+                  <a:srgbClr val="8A5F00"/>
+                </a:solidFill>
+                <a:latin typeface="Calibri" pitchFamily="34" charset="0"/>
+                <a:ea typeface="Calibri" pitchFamily="34" charset="-122"/>
+                <a:cs typeface="Calibri" pitchFamily="34" charset="-120"/>
+              </a:rPr>
+              <a:t>DERIVED</a:t>
+            </a:r>
+            <a:endParaRPr lang="en-US" sz="1000" dirty="0"/>
+          </a:p>
+        </p:txBody>
+      </p:sp>
+      <p:sp>
+        <p:nvSpPr>
+          <p:cNvPr id="16" name="Effort value"/>
+          <p:cNvSpPr txBox="1"/>
+          <p:nvPr/>
+        </p:nvSpPr>
+        <p:spPr>
+          <a:xfrm>
+            <a:off x="8001000" y="4069080"/>
+            <a:ext cx="3383280" cy="594360"/>
+          </a:xfrm>
+          <a:prstGeom prst="rect">
+            <a:avLst/>
+          </a:prstGeom>
+          <a:noFill/>
+          <a:ln/>
+        </p:spPr>
+        <p:txBody>
+          <a:bodyPr wrap="square" lIns="0" tIns="0" rIns="0" bIns="0" rtlCol="0" anchor="ctr"/>
+          <a:lstStyle/>
+          <a:p>
+            <a:pPr indent="0" marL="0">
+              <a:buNone/>
+            </a:pPr>
+            <a:r>
+              <a:rPr lang="en-US" sz="3200" b="1" dirty="0">
+                <a:solidFill>
+                  <a:srgbClr val="0D5E72"/>
+                </a:solidFill>
+                <a:latin typeface="Calibri" pitchFamily="34" charset="0"/>
+                <a:ea typeface="Calibri" pitchFamily="34" charset="-122"/>
+                <a:cs typeface="Calibri" pitchFamily="34" charset="-120"/>
+              </a:rPr>
+              <a:t>40 FTE-years</a:t>
+            </a:r>
+            <a:endParaRPr lang="en-US" sz="3200" dirty="0"/>
+          </a:p>
+        </p:txBody>
+      </p:sp>
+      <p:sp>
+        <p:nvSpPr>
+          <p:cNvPr id="17" name="Effort text"/>
+          <p:cNvSpPr txBox="1"/>
+          <p:nvPr/>
+        </p:nvSpPr>
+        <p:spPr>
+          <a:xfrm>
+            <a:off x="8001000" y="4709160"/>
+            <a:ext cx="3383280" cy="1005840"/>
+          </a:xfrm>
+          <a:prstGeom prst="rect">
+            <a:avLst/>
+          </a:prstGeom>
+          <a:noFill/>
+          <a:ln/>
+        </p:spPr>
+        <p:txBody>
+          <a:bodyPr wrap="square" lIns="0" tIns="0" rIns="0" bIns="0" rtlCol="0" anchor="t"/>
+          <a:lstStyle/>
+          <a:p>
+            <a:pPr indent="0" marL="0">
+              <a:buNone/>
+            </a:pPr>
+            <a:r>
+              <a:rPr lang="en-US" sz="1400" dirty="0">
                 <a:solidFill>
                   <a:srgbClr val="15222A"/>
                 </a:solidFill>
@@ -6351,78 +6388,15 @@
                 <a:ea typeface="Calibri" pitchFamily="34" charset="-122"/>
                 <a:cs typeface="Calibri" pitchFamily="34" charset="-120"/>
               </a:rPr>
-              <a:t>How to read this</a:t>
+              <a:t>13,783 person-days of 8 hours behind the 120 listed projects. A software company would need the same effort.</a:t>
             </a:r>
-            <a:endParaRPr lang="en-US" sz="1200" dirty="0"/>
-          </a:p>
-          <a:p>
-            <a:pPr marL="342900" indent="-342900">
-              <a:spcAft>
-                <a:spcPts val="400"/>
-              </a:spcAft>
-              <a:buSzPct val="100000"/>
-              <a:buChar char="•"/>
-            </a:pPr>
-            <a:r>
-              <a:rPr lang="en-US" sz="1200" dirty="0">
-                <a:solidFill>
-                  <a:srgbClr val="15222A"/>
-                </a:solidFill>
-                <a:latin typeface="Calibri" pitchFamily="34" charset="0"/>
-                <a:ea typeface="Calibri" pitchFamily="34" charset="-122"/>
-                <a:cs typeface="Calibri" pitchFamily="34" charset="-120"/>
-              </a:rPr>
-              <a:t>Hours and FTE are the owner's figures; FTE = hours / 2,740.</a:t>
-            </a:r>
-            <a:endParaRPr lang="en-US" sz="1200" dirty="0"/>
-          </a:p>
-          <a:p>
-            <a:pPr marL="342900" indent="-342900">
-              <a:spcAft>
-                <a:spcPts val="400"/>
-              </a:spcAft>
-              <a:buSzPct val="100000"/>
-              <a:buChar char="•"/>
-            </a:pPr>
-            <a:r>
-              <a:rPr lang="en-US" sz="1200" dirty="0">
-                <a:solidFill>
-                  <a:srgbClr val="15222A"/>
-                </a:solidFill>
-                <a:latin typeface="Calibri" pitchFamily="34" charset="0"/>
-                <a:ea typeface="Calibri" pitchFamily="34" charset="-122"/>
-                <a:cs typeface="Calibri" pitchFamily="34" charset="-120"/>
-              </a:rPr>
-              <a:t>About 120 shipments a year follows from 36,000 min / 300 min saved each (DERIVED).</a:t>
-            </a:r>
-            <a:endParaRPr lang="en-US" sz="1200" dirty="0"/>
-          </a:p>
-          <a:p>
-            <a:pPr marL="342900" indent="-342900">
-              <a:spcAft>
-                <a:spcPts val="400"/>
-              </a:spcAft>
-              <a:buSzPct val="100000"/>
-              <a:buChar char="•"/>
-            </a:pPr>
-            <a:r>
-              <a:rPr lang="en-US" sz="1200" dirty="0">
-                <a:solidFill>
-                  <a:srgbClr val="15222A"/>
-                </a:solidFill>
-                <a:latin typeface="Calibri" pitchFamily="34" charset="0"/>
-                <a:ea typeface="Calibri" pitchFamily="34" charset="-122"/>
-                <a:cs typeface="Calibri" pitchFamily="34" charset="-120"/>
-              </a:rPr>
-              <a:t>"1 FTE equals" = runs a year whose saved time adds up to 2,740 h.</a:t>
-            </a:r>
-            <a:endParaRPr lang="en-US" sz="1200" dirty="0"/>
-          </a:p>
-        </p:txBody>
-      </p:sp>
-      <p:sp>
-        <p:nvSpPr>
-          <p:cNvPr id="15" name="Basis note"/>
+            <a:endParaRPr lang="en-US" sz="1400" dirty="0"/>
+          </a:p>
+        </p:txBody>
+      </p:sp>
+      <p:sp>
+        <p:nvSpPr>
+          <p:cNvPr id="18" name="Basis note"/>
           <p:cNvSpPr txBox="1"/>
           <p:nvPr/>
         </p:nvSpPr>
@@ -6453,7 +6427,7 @@
                 <a:ea typeface="Calibri" pitchFamily="34" charset="-122"/>
                 <a:cs typeface="Calibri" pitchFamily="34" charset="-120"/>
               </a:rPr>
-              <a:t>Effort = people's working time. Man-day = 8 hours; 1 FTE = 2,740 hours a year. Reductions use the lower figure of a stated range (report preparation 4-5 h taken as 4 h). The project list gives no frequency for slab identification or report preparation, so only the per-run saving is stated.</a:t>
+              <a:t>Effort = people's working time. Man-day = 8 hours; 1 FTE = 2,740 hours a year. "1 FTE equals" = runs a year whose saved time adds up to 2,740 hours. Reductions use the lower figure of a stated range (4-5 h taken as 4 h). The list gives no frequency for slab identification or report preparation, so only the saving per run is stated.</a:t>
             </a:r>
             <a:endParaRPr lang="en-US" sz="1100" dirty="0"/>
           </a:p>
@@ -6567,7 +6541,7 @@
                 <a:ea typeface="Calibri" pitchFamily="34" charset="-122"/>
                 <a:cs typeface="Calibri" pitchFamily="34" charset="-120"/>
               </a:rPr>
-              <a:t>TAT and productivity: faster turnaround, more output</a:t>
+              <a:t>Productivity: faster turnaround, more output</a:t>
             </a:r>
             <a:endParaRPr lang="en-US" sz="3000" dirty="0"/>
           </a:p>
@@ -6582,7 +6556,7 @@
         <p:spPr>
           <a:xfrm>
             <a:off x="548640" y="1234440"/>
-            <a:ext cx="5486400" cy="320040"/>
+            <a:ext cx="4206240" cy="320040"/>
           </a:xfrm>
           <a:prstGeom prst="rect">
             <a:avLst/>
@@ -6620,7 +6594,7 @@
         </p:nvSpPr>
         <p:spPr>
           <a:xfrm>
-            <a:off x="5166360" y="1280160"/>
+            <a:off x="5394960" y="1280160"/>
             <a:ext cx="868680" cy="219456"/>
           </a:xfrm>
           <a:prstGeom prst="roundRect">
@@ -6667,7 +6641,7 @@
         </p:nvGraphicFramePr>
         <p:xfrm>
           <a:off x="548640" y="1600200"/>
-          <a:ext cx="5669280" cy="2926080"/>
+          <a:ext cx="5852160" cy="2834640"/>
         </p:xfrm>
         <a:graphic xmlns:a="http://schemas.openxmlformats.org/drawingml/2006/main">
           <a:graphicData uri="http://schemas.openxmlformats.org/drawingml/2006/chart">
@@ -6677,14 +6651,14 @@
       </p:graphicFrame>
       <p:sp>
         <p:nvSpPr>
-          <p:cNvPr id="6" name="SMP2 panel"/>
+          <p:cNvPr id="6" name="Output chip"/>
           <p:cNvSpPr/>
           <p:nvPr/>
         </p:nvSpPr>
         <p:spPr>
           <a:xfrm>
-            <a:off x="6492240" y="1234440"/>
-            <a:ext cx="5120640" cy="3291840"/>
+            <a:off x="548640" y="4754880"/>
+            <a:ext cx="5852160" cy="777240"/>
           </a:xfrm>
           <a:prstGeom prst="rect">
             <a:avLst/>
@@ -6702,14 +6676,14 @@
       </p:sp>
       <p:sp>
         <p:nvSpPr>
-          <p:cNvPr id="7" name="SMP2 heading"/>
+          <p:cNvPr id="7" name="Output value"/>
           <p:cNvSpPr txBox="1"/>
           <p:nvPr/>
         </p:nvSpPr>
         <p:spPr>
           <a:xfrm>
-            <a:off x="6675120" y="1325880"/>
-            <a:ext cx="3931920" cy="274320"/>
+            <a:off x="685800" y="4800600"/>
+            <a:ext cx="1554480" cy="685800"/>
           </a:xfrm>
           <a:prstGeom prst="rect">
             <a:avLst/>
@@ -6725,7 +6699,46 @@
               <a:buNone/>
             </a:pPr>
             <a:r>
-              <a:rPr lang="en-US" sz="1400" b="1" dirty="0">
+              <a:rPr lang="en-US" sz="2000" b="1" dirty="0">
+                <a:solidFill>
+                  <a:srgbClr val="0D5E72"/>
+                </a:solidFill>
+                <a:latin typeface="Calibri" pitchFamily="34" charset="0"/>
+                <a:ea typeface="Calibri" pitchFamily="34" charset="-122"/>
+                <a:cs typeface="Calibri" pitchFamily="34" charset="-120"/>
+              </a:rPr>
+              <a:t>+70 t/day</a:t>
+            </a:r>
+            <a:endParaRPr lang="en-US" sz="2000" dirty="0"/>
+          </a:p>
+        </p:txBody>
+      </p:sp>
+      <p:sp>
+        <p:nvSpPr>
+          <p:cNvPr id="8" name="Output text"/>
+          <p:cNvSpPr txBox="1"/>
+          <p:nvPr/>
+        </p:nvSpPr>
+        <p:spPr>
+          <a:xfrm>
+            <a:off x="2286000" y="4800600"/>
+            <a:ext cx="3977640" cy="685800"/>
+          </a:xfrm>
+          <a:prstGeom prst="rect">
+            <a:avLst/>
+          </a:prstGeom>
+          <a:noFill/>
+          <a:ln/>
+        </p:spPr>
+        <p:txBody>
+          <a:bodyPr wrap="square" lIns="0" tIns="0" rIns="0" bIns="0" rtlCol="0" anchor="ctr"/>
+          <a:lstStyle/>
+          <a:p>
+            <a:pPr indent="0" marL="0">
+              <a:buNone/>
+            </a:pPr>
+            <a:r>
+              <a:rPr lang="en-US" sz="1200" dirty="0">
                 <a:solidFill>
                   <a:srgbClr val="15222A"/>
                 </a:solidFill>
@@ -6733,21 +6746,21 @@
                 <a:ea typeface="Calibri" pitchFamily="34" charset="-122"/>
                 <a:cs typeface="Calibri" pitchFamily="34" charset="-120"/>
               </a:rPr>
-              <a:t>SMP2 Digital Transformation, Hazira Operations</a:t>
+              <a:t>blast-furnace production from a raw-material optimisation model</a:t>
             </a:r>
-            <a:endParaRPr lang="en-US" sz="1400" dirty="0"/>
-          </a:p>
-        </p:txBody>
-      </p:sp>
-      <p:sp>
-        <p:nvSpPr>
-          <p:cNvPr id="8" name="STATED tag"/>
+            <a:endParaRPr lang="en-US" sz="1200" dirty="0"/>
+          </a:p>
+        </p:txBody>
+      </p:sp>
+      <p:sp>
+        <p:nvSpPr>
+          <p:cNvPr id="9" name="STATED tag"/>
           <p:cNvSpPr/>
           <p:nvPr/>
         </p:nvSpPr>
         <p:spPr>
           <a:xfrm>
-            <a:off x="10607040" y="1353312"/>
+            <a:off x="5532120" y="4480560"/>
             <a:ext cx="868680" cy="219456"/>
           </a:xfrm>
           <a:prstGeom prst="roundRect">
@@ -6788,14 +6801,39 @@
       </p:sp>
       <p:sp>
         <p:nvSpPr>
-          <p:cNvPr id="9" name="SMP2 period"/>
+          <p:cNvPr id="10" name="Potential panel"/>
+          <p:cNvSpPr/>
+          <p:nvPr/>
+        </p:nvSpPr>
+        <p:spPr>
+          <a:xfrm>
+            <a:off x="6675120" y="1234440"/>
+            <a:ext cx="4937760" cy="4297680"/>
+          </a:xfrm>
+          <a:prstGeom prst="rect">
+            <a:avLst/>
+          </a:prstGeom>
+          <a:solidFill>
+            <a:srgbClr val="EEF3F5"/>
+          </a:solidFill>
+          <a:ln w="15875">
+            <a:solidFill>
+              <a:srgbClr val="0D5E72"/>
+            </a:solidFill>
+            <a:prstDash val="dash"/>
+          </a:ln>
+        </p:spPr>
+      </p:sp>
+      <p:sp>
+        <p:nvSpPr>
+          <p:cNvPr id="11" name="Potential heading"/>
           <p:cNvSpPr txBox="1"/>
           <p:nvPr/>
         </p:nvSpPr>
         <p:spPr>
           <a:xfrm>
-            <a:off x="6675120" y="1627632"/>
-            <a:ext cx="4754880" cy="256032"/>
+            <a:off x="6858000" y="1325880"/>
+            <a:ext cx="3108960" cy="292608"/>
           </a:xfrm>
           <a:prstGeom prst="rect">
             <a:avLst/>
@@ -6805,6 +6843,92 @@
         </p:spPr>
         <p:txBody>
           <a:bodyPr wrap="square" lIns="0" tIns="0" rIns="0" bIns="0" rtlCol="0" anchor="ctr"/>
+          <a:lstStyle/>
+          <a:p>
+            <a:pPr indent="0" marL="0">
+              <a:buNone/>
+            </a:pPr>
+            <a:r>
+              <a:rPr lang="en-US" sz="1400" b="1" dirty="0">
+                <a:solidFill>
+                  <a:srgbClr val="15222A"/>
+                </a:solidFill>
+                <a:latin typeface="Calibri" pitchFamily="34" charset="0"/>
+                <a:ea typeface="Calibri" pitchFamily="34" charset="-122"/>
+                <a:cs typeface="Calibri" pitchFamily="34" charset="-120"/>
+              </a:rPr>
+              <a:t>Furnace heat cycle: potential</a:t>
+            </a:r>
+            <a:endParaRPr lang="en-US" sz="1400" dirty="0"/>
+          </a:p>
+        </p:txBody>
+      </p:sp>
+      <p:sp>
+        <p:nvSpPr>
+          <p:cNvPr id="12" name="POTENTIAL tag"/>
+          <p:cNvSpPr/>
+          <p:nvPr/>
+        </p:nvSpPr>
+        <p:spPr>
+          <a:xfrm>
+            <a:off x="10378440" y="1362456"/>
+            <a:ext cx="1051560" cy="219456"/>
+          </a:xfrm>
+          <a:prstGeom prst="roundRect">
+            <a:avLst>
+              <a:gd name="adj" fmla="val 20833"/>
+            </a:avLst>
+          </a:prstGeom>
+          <a:solidFill>
+            <a:srgbClr val="FFFFFF"/>
+          </a:solidFill>
+          <a:ln w="12700">
+            <a:solidFill>
+              <a:srgbClr val="0D5E72"/>
+            </a:solidFill>
+          </a:ln>
+        </p:spPr>
+        <p:txBody>
+          <a:bodyPr wrap="square" lIns="0" tIns="0" rIns="0" bIns="0" rtlCol="0" anchor="ctr"/>
+          <a:lstStyle/>
+          <a:p>
+            <a:pPr algn="ctr" indent="0" marL="0">
+              <a:buNone/>
+            </a:pPr>
+            <a:r>
+              <a:rPr lang="en-US" sz="1000" b="1" dirty="0">
+                <a:solidFill>
+                  <a:srgbClr val="0D5E72"/>
+                </a:solidFill>
+                <a:latin typeface="Calibri" pitchFamily="34" charset="0"/>
+                <a:ea typeface="Calibri" pitchFamily="34" charset="-122"/>
+                <a:cs typeface="Calibri" pitchFamily="34" charset="-120"/>
+              </a:rPr>
+              <a:t>POTENTIAL</a:t>
+            </a:r>
+            <a:endParaRPr lang="en-US" sz="1000" dirty="0"/>
+          </a:p>
+        </p:txBody>
+      </p:sp>
+      <p:sp>
+        <p:nvSpPr>
+          <p:cNvPr id="13" name="Potential period"/>
+          <p:cNvSpPr txBox="1"/>
+          <p:nvPr/>
+        </p:nvSpPr>
+        <p:spPr>
+          <a:xfrm>
+            <a:off x="6858000" y="1664208"/>
+            <a:ext cx="4572000" cy="457200"/>
+          </a:xfrm>
+          <a:prstGeom prst="rect">
+            <a:avLst/>
+          </a:prstGeom>
+          <a:noFill/>
+          <a:ln/>
+        </p:spPr>
+        <p:txBody>
+          <a:bodyPr wrap="square" lIns="0" tIns="0" rIns="0" bIns="0" rtlCol="0" anchor="t"/>
           <a:lstStyle/>
           <a:p>
             <a:pPr indent="0" marL="0">
@@ -6819,7 +6943,7 @@
                 <a:ea typeface="Calibri" pitchFamily="34" charset="-122"/>
                 <a:cs typeface="Calibri" pitchFamily="34" charset="-120"/>
               </a:rPr>
-              <a:t>September 2026 figures: one month, not annualised</a:t>
+              <a:t>Project in progress. Analysis of September 2026 (one month); not yet realised, not annualised.</a:t>
             </a:r>
             <a:endParaRPr lang="en-US" sz="1100" dirty="0"/>
           </a:p>
@@ -6827,14 +6951,14 @@
       </p:sp>
       <p:sp>
         <p:nvSpPr>
-          <p:cNvPr id="10" name="SMP2 value"/>
+          <p:cNvPr id="14" name="Potential value"/>
           <p:cNvSpPr txBox="1"/>
           <p:nvPr/>
         </p:nvSpPr>
         <p:spPr>
           <a:xfrm>
-            <a:off x="6675120" y="1901952"/>
-            <a:ext cx="1737360" cy="548640"/>
+            <a:off x="6858000" y="2148840"/>
+            <a:ext cx="1554480" cy="548640"/>
           </a:xfrm>
           <a:prstGeom prst="rect">
             <a:avLst/>
@@ -6866,14 +6990,14 @@
       </p:sp>
       <p:sp>
         <p:nvSpPr>
-          <p:cNvPr id="11" name="SMP2 text"/>
+          <p:cNvPr id="15" name="Potential text"/>
           <p:cNvSpPr txBox="1"/>
           <p:nvPr/>
         </p:nvSpPr>
         <p:spPr>
           <a:xfrm>
-            <a:off x="8458200" y="1874520"/>
-            <a:ext cx="3017520" cy="640080"/>
+            <a:off x="8503920" y="2103120"/>
+            <a:ext cx="2971800" cy="685800"/>
           </a:xfrm>
           <a:prstGeom prst="rect">
             <a:avLst/>
@@ -6897,7 +7021,7 @@
                 <a:ea typeface="Calibri" pitchFamily="34" charset="-122"/>
                 <a:cs typeface="Calibri" pitchFamily="34" charset="-120"/>
               </a:rPr>
-              <a:t>recoverable furnace time, about 15 additional heats, by bringing slower heats to the 79 min median tap-to-tap time.</a:t>
+              <a:t>of recoverable furnace time, about 15 additional heats, by bringing slower heats to the 79 min median tap-to-tap time.</a:t>
             </a:r>
             <a:endParaRPr lang="en-US" sz="1200" dirty="0"/>
           </a:p>
@@ -6905,14 +7029,14 @@
       </p:sp>
       <p:sp>
         <p:nvSpPr>
-          <p:cNvPr id="12" name="SMP2 chart heading"/>
+          <p:cNvPr id="16" name="Potential chart heading"/>
           <p:cNvSpPr txBox="1"/>
           <p:nvPr/>
         </p:nvSpPr>
         <p:spPr>
           <a:xfrm>
-            <a:off x="6675120" y="2606040"/>
-            <a:ext cx="4754880" cy="256032"/>
+            <a:off x="6858000" y="2926080"/>
+            <a:ext cx="4572000" cy="256032"/>
           </a:xfrm>
           <a:prstGeom prst="rect">
             <a:avLst/>
@@ -6944,13 +7068,13 @@
       </p:sp>
       <p:graphicFrame>
         <p:nvGraphicFramePr>
-          <p:cNvPr id="13" name="SMP2 chart" descr=""/>
+          <p:cNvPr id="17" name="Potential chart" descr=""/>
           <p:cNvGraphicFramePr/>
           <p:nvPr/>
         </p:nvGraphicFramePr>
         <p:xfrm>
-          <a:off x="6583680" y="2834640"/>
-          <a:ext cx="4937760" cy="1097280"/>
+          <a:off x="6766560" y="3154680"/>
+          <a:ext cx="4754880" cy="1371600"/>
         </p:xfrm>
         <a:graphic xmlns:a="http://schemas.openxmlformats.org/drawingml/2006/main">
           <a:graphicData uri="http://schemas.openxmlformats.org/drawingml/2006/chart">
@@ -6960,14 +7084,14 @@
       </p:graphicFrame>
       <p:sp>
         <p:nvSpPr>
-          <p:cNvPr id="14" name="SMP2 Conarc"/>
+          <p:cNvPr id="18" name="Potential converter"/>
           <p:cNvSpPr txBox="1"/>
           <p:nvPr/>
         </p:nvSpPr>
         <p:spPr>
           <a:xfrm>
-            <a:off x="6675120" y="4023360"/>
-            <a:ext cx="4754880" cy="365760"/>
+            <a:off x="6858000" y="4709160"/>
+            <a:ext cx="4572000" cy="548640"/>
           </a:xfrm>
           <a:prstGeom prst="rect">
             <a:avLst/>
@@ -6991,7 +7115,7 @@
                 <a:ea typeface="Calibri" pitchFamily="34" charset="-122"/>
                 <a:cs typeface="Calibri" pitchFamily="34" charset="-120"/>
               </a:rPr>
-              <a:t>Aligning Conarc3 to Conarc2 adds about 1.8 h more furnace time.</a:t>
+              <a:t>Aligning the two converters adds about 1.8 h more furnace time.</a:t>
             </a:r>
             <a:endParaRPr lang="en-US" sz="1200" dirty="0"/>
           </a:p>
@@ -6999,409 +7123,14 @@
       </p:sp>
       <p:sp>
         <p:nvSpPr>
-          <p:cNvPr id="15" name="Productivity heading"/>
+          <p:cNvPr id="19" name="Basis note"/>
           <p:cNvSpPr txBox="1"/>
           <p:nvPr/>
         </p:nvSpPr>
         <p:spPr>
           <a:xfrm>
-            <a:off x="548640" y="4663440"/>
-            <a:ext cx="5486400" cy="320040"/>
-          </a:xfrm>
-          <a:prstGeom prst="rect">
-            <a:avLst/>
-          </a:prstGeom>
-          <a:noFill/>
-          <a:ln/>
-        </p:spPr>
-        <p:txBody>
-          <a:bodyPr wrap="square" lIns="0" tIns="0" rIns="0" bIns="0" rtlCol="0" anchor="ctr"/>
-          <a:lstStyle/>
-          <a:p>
-            <a:pPr indent="0" marL="0">
-              <a:buNone/>
-            </a:pPr>
-            <a:r>
-              <a:rPr lang="en-US" sz="1500" b="1" dirty="0">
-                <a:solidFill>
-                  <a:srgbClr val="15222A"/>
-                </a:solidFill>
-                <a:latin typeface="Calibri" pitchFamily="34" charset="0"/>
-                <a:ea typeface="Calibri" pitchFamily="34" charset="-122"/>
-                <a:cs typeface="Calibri" pitchFamily="34" charset="-120"/>
-              </a:rPr>
-              <a:t>Other productivity gains</a:t>
-            </a:r>
-            <a:endParaRPr lang="en-US" sz="1500" dirty="0"/>
-          </a:p>
-        </p:txBody>
-      </p:sp>
-      <p:sp>
-        <p:nvSpPr>
-          <p:cNvPr id="16" name="STATED tag"/>
-          <p:cNvSpPr/>
-          <p:nvPr/>
-        </p:nvSpPr>
-        <p:spPr>
-          <a:xfrm>
-            <a:off x="3017520" y="4709160"/>
-            <a:ext cx="868680" cy="219456"/>
-          </a:xfrm>
-          <a:prstGeom prst="roundRect">
-            <a:avLst>
-              <a:gd name="adj" fmla="val 20833"/>
-            </a:avLst>
-          </a:prstGeom>
-          <a:solidFill>
-            <a:srgbClr val="FFFFFF"/>
-          </a:solidFill>
-          <a:ln w="12700">
-            <a:solidFill>
-              <a:srgbClr val="1F7A45"/>
-            </a:solidFill>
-          </a:ln>
-        </p:spPr>
-        <p:txBody>
-          <a:bodyPr wrap="square" lIns="0" tIns="0" rIns="0" bIns="0" rtlCol="0" anchor="ctr"/>
-          <a:lstStyle/>
-          <a:p>
-            <a:pPr algn="ctr" indent="0" marL="0">
-              <a:buNone/>
-            </a:pPr>
-            <a:r>
-              <a:rPr lang="en-US" sz="1000" b="1" dirty="0">
-                <a:solidFill>
-                  <a:srgbClr val="1F7A45"/>
-                </a:solidFill>
-                <a:latin typeface="Calibri" pitchFamily="34" charset="0"/>
-                <a:ea typeface="Calibri" pitchFamily="34" charset="-122"/>
-                <a:cs typeface="Calibri" pitchFamily="34" charset="-120"/>
-              </a:rPr>
-              <a:t>STATED</a:t>
-            </a:r>
-            <a:endParaRPr lang="en-US" sz="1000" dirty="0"/>
-          </a:p>
-        </p:txBody>
-      </p:sp>
-      <p:sp>
-        <p:nvSpPr>
-          <p:cNvPr id="17" name="Chip 1"/>
-          <p:cNvSpPr/>
-          <p:nvPr/>
-        </p:nvSpPr>
-        <p:spPr>
-          <a:xfrm>
-            <a:off x="548640" y="5029200"/>
-            <a:ext cx="3611880" cy="777240"/>
-          </a:xfrm>
-          <a:prstGeom prst="rect">
-            <a:avLst/>
-          </a:prstGeom>
-          <a:solidFill>
-            <a:srgbClr val="EEF3F5"/>
-          </a:solidFill>
-          <a:ln w="9525">
-            <a:solidFill>
-              <a:srgbClr val="D3DBE0"/>
-            </a:solidFill>
-            <a:prstDash val="solid"/>
-          </a:ln>
-        </p:spPr>
-      </p:sp>
-      <p:sp>
-        <p:nvSpPr>
-          <p:cNvPr id="18" name="Chip value 1"/>
-          <p:cNvSpPr txBox="1"/>
-          <p:nvPr/>
-        </p:nvSpPr>
-        <p:spPr>
-          <a:xfrm>
-            <a:off x="685800" y="5074920"/>
-            <a:ext cx="1417320" cy="685800"/>
-          </a:xfrm>
-          <a:prstGeom prst="rect">
-            <a:avLst/>
-          </a:prstGeom>
-          <a:noFill/>
-          <a:ln/>
-        </p:spPr>
-        <p:txBody>
-          <a:bodyPr wrap="square" lIns="0" tIns="0" rIns="0" bIns="0" rtlCol="0" anchor="ctr"/>
-          <a:lstStyle/>
-          <a:p>
-            <a:pPr indent="0" marL="0">
-              <a:buNone/>
-            </a:pPr>
-            <a:r>
-              <a:rPr lang="en-US" sz="1800" b="1" dirty="0">
-                <a:solidFill>
-                  <a:srgbClr val="0D5E72"/>
-                </a:solidFill>
-                <a:latin typeface="Calibri" pitchFamily="34" charset="0"/>
-                <a:ea typeface="Calibri" pitchFamily="34" charset="-122"/>
-                <a:cs typeface="Calibri" pitchFamily="34" charset="-120"/>
-              </a:rPr>
-              <a:t>+70 t/day</a:t>
-            </a:r>
-            <a:endParaRPr lang="en-US" sz="1800" dirty="0"/>
-          </a:p>
-        </p:txBody>
-      </p:sp>
-      <p:sp>
-        <p:nvSpPr>
-          <p:cNvPr id="19" name="Chip text 1"/>
-          <p:cNvSpPr txBox="1"/>
-          <p:nvPr/>
-        </p:nvSpPr>
-        <p:spPr>
-          <a:xfrm>
-            <a:off x="2148840" y="5074920"/>
-            <a:ext cx="1920240" cy="685800"/>
-          </a:xfrm>
-          <a:prstGeom prst="rect">
-            <a:avLst/>
-          </a:prstGeom>
-          <a:noFill/>
-          <a:ln/>
-        </p:spPr>
-        <p:txBody>
-          <a:bodyPr wrap="square" lIns="0" tIns="0" rIns="0" bIns="0" rtlCol="0" anchor="ctr"/>
-          <a:lstStyle/>
-          <a:p>
-            <a:pPr indent="0" marL="0">
-              <a:buNone/>
-            </a:pPr>
-            <a:r>
-              <a:rPr lang="en-US" sz="1200" dirty="0">
-                <a:solidFill>
-                  <a:srgbClr val="15222A"/>
-                </a:solidFill>
-                <a:latin typeface="Calibri" pitchFamily="34" charset="0"/>
-                <a:ea typeface="Calibri" pitchFamily="34" charset="-122"/>
-                <a:cs typeface="Calibri" pitchFamily="34" charset="-120"/>
-              </a:rPr>
-              <a:t>blast-furnace production (C-MARVEL)</a:t>
-            </a:r>
-            <a:endParaRPr lang="en-US" sz="1200" dirty="0"/>
-          </a:p>
-        </p:txBody>
-      </p:sp>
-      <p:sp>
-        <p:nvSpPr>
-          <p:cNvPr id="20" name="Chip 2"/>
-          <p:cNvSpPr/>
-          <p:nvPr/>
-        </p:nvSpPr>
-        <p:spPr>
-          <a:xfrm>
-            <a:off x="4297680" y="5029200"/>
-            <a:ext cx="3611880" cy="777240"/>
-          </a:xfrm>
-          <a:prstGeom prst="rect">
-            <a:avLst/>
-          </a:prstGeom>
-          <a:solidFill>
-            <a:srgbClr val="EEF3F5"/>
-          </a:solidFill>
-          <a:ln w="9525">
-            <a:solidFill>
-              <a:srgbClr val="D3DBE0"/>
-            </a:solidFill>
-            <a:prstDash val="solid"/>
-          </a:ln>
-        </p:spPr>
-      </p:sp>
-      <p:sp>
-        <p:nvSpPr>
-          <p:cNvPr id="21" name="Chip value 2"/>
-          <p:cNvSpPr txBox="1"/>
-          <p:nvPr/>
-        </p:nvSpPr>
-        <p:spPr>
-          <a:xfrm>
-            <a:off x="4434840" y="5074920"/>
-            <a:ext cx="1417320" cy="685800"/>
-          </a:xfrm>
-          <a:prstGeom prst="rect">
-            <a:avLst/>
-          </a:prstGeom>
-          <a:noFill/>
-          <a:ln/>
-        </p:spPr>
-        <p:txBody>
-          <a:bodyPr wrap="square" lIns="0" tIns="0" rIns="0" bIns="0" rtlCol="0" anchor="ctr"/>
-          <a:lstStyle/>
-          <a:p>
-            <a:pPr indent="0" marL="0">
-              <a:buNone/>
-            </a:pPr>
-            <a:r>
-              <a:rPr lang="en-US" sz="1800" b="1" dirty="0">
-                <a:solidFill>
-                  <a:srgbClr val="0D5E72"/>
-                </a:solidFill>
-                <a:latin typeface="Calibri" pitchFamily="34" charset="0"/>
-                <a:ea typeface="Calibri" pitchFamily="34" charset="-122"/>
-                <a:cs typeface="Calibri" pitchFamily="34" charset="-120"/>
-              </a:rPr>
-              <a:t>₹615 / ton</a:t>
-            </a:r>
-            <a:endParaRPr lang="en-US" sz="1800" dirty="0"/>
-          </a:p>
-        </p:txBody>
-      </p:sp>
-      <p:sp>
-        <p:nvSpPr>
-          <p:cNvPr id="22" name="Chip text 2"/>
-          <p:cNvSpPr txBox="1"/>
-          <p:nvPr/>
-        </p:nvSpPr>
-        <p:spPr>
-          <a:xfrm>
-            <a:off x="5897880" y="5074920"/>
-            <a:ext cx="1920240" cy="685800"/>
-          </a:xfrm>
-          <a:prstGeom prst="rect">
-            <a:avLst/>
-          </a:prstGeom>
-          <a:noFill/>
-          <a:ln/>
-        </p:spPr>
-        <p:txBody>
-          <a:bodyPr wrap="square" lIns="0" tIns="0" rIns="0" bIns="0" rtlCol="0" anchor="ctr"/>
-          <a:lstStyle/>
-          <a:p>
-            <a:pPr indent="0" marL="0">
-              <a:buNone/>
-            </a:pPr>
-            <a:r>
-              <a:rPr lang="en-US" sz="1200" dirty="0">
-                <a:solidFill>
-                  <a:srgbClr val="15222A"/>
-                </a:solidFill>
-                <a:latin typeface="Calibri" pitchFamily="34" charset="0"/>
-                <a:ea typeface="Calibri" pitchFamily="34" charset="-122"/>
-                <a:cs typeface="Calibri" pitchFamily="34" charset="-120"/>
-              </a:rPr>
-              <a:t>lower cost of production, Hazira (C-MARVEL)</a:t>
-            </a:r>
-            <a:endParaRPr lang="en-US" sz="1200" dirty="0"/>
-          </a:p>
-        </p:txBody>
-      </p:sp>
-      <p:sp>
-        <p:nvSpPr>
-          <p:cNvPr id="23" name="Chip 3"/>
-          <p:cNvSpPr/>
-          <p:nvPr/>
-        </p:nvSpPr>
-        <p:spPr>
-          <a:xfrm>
-            <a:off x="8046720" y="5029200"/>
-            <a:ext cx="3611880" cy="777240"/>
-          </a:xfrm>
-          <a:prstGeom prst="rect">
-            <a:avLst/>
-          </a:prstGeom>
-          <a:solidFill>
-            <a:srgbClr val="EEF3F5"/>
-          </a:solidFill>
-          <a:ln w="9525">
-            <a:solidFill>
-              <a:srgbClr val="D3DBE0"/>
-            </a:solidFill>
-            <a:prstDash val="solid"/>
-          </a:ln>
-        </p:spPr>
-      </p:sp>
-      <p:sp>
-        <p:nvSpPr>
-          <p:cNvPr id="24" name="Chip value 3"/>
-          <p:cNvSpPr txBox="1"/>
-          <p:nvPr/>
-        </p:nvSpPr>
-        <p:spPr>
-          <a:xfrm>
-            <a:off x="8183880" y="5074920"/>
-            <a:ext cx="1417320" cy="685800"/>
-          </a:xfrm>
-          <a:prstGeom prst="rect">
-            <a:avLst/>
-          </a:prstGeom>
-          <a:noFill/>
-          <a:ln/>
-        </p:spPr>
-        <p:txBody>
-          <a:bodyPr wrap="square" lIns="0" tIns="0" rIns="0" bIns="0" rtlCol="0" anchor="ctr"/>
-          <a:lstStyle/>
-          <a:p>
-            <a:pPr indent="0" marL="0">
-              <a:buNone/>
-            </a:pPr>
-            <a:r>
-              <a:rPr lang="en-US" sz="1800" b="1" dirty="0">
-                <a:solidFill>
-                  <a:srgbClr val="0D5E72"/>
-                </a:solidFill>
-                <a:latin typeface="Calibri" pitchFamily="34" charset="0"/>
-                <a:ea typeface="Calibri" pitchFamily="34" charset="-122"/>
-                <a:cs typeface="Calibri" pitchFamily="34" charset="-120"/>
-              </a:rPr>
-              <a:t>30% lower</a:t>
-            </a:r>
-            <a:endParaRPr lang="en-US" sz="1800" dirty="0"/>
-          </a:p>
-        </p:txBody>
-      </p:sp>
-      <p:sp>
-        <p:nvSpPr>
-          <p:cNvPr id="25" name="Chip text 3"/>
-          <p:cNvSpPr txBox="1"/>
-          <p:nvPr/>
-        </p:nvSpPr>
-        <p:spPr>
-          <a:xfrm>
-            <a:off x="9646920" y="5074920"/>
-            <a:ext cx="1920240" cy="685800"/>
-          </a:xfrm>
-          <a:prstGeom prst="rect">
-            <a:avLst/>
-          </a:prstGeom>
-          <a:noFill/>
-          <a:ln/>
-        </p:spPr>
-        <p:txBody>
-          <a:bodyPr wrap="square" lIns="0" tIns="0" rIns="0" bIns="0" rtlCol="0" anchor="ctr"/>
-          <a:lstStyle/>
-          <a:p>
-            <a:pPr indent="0" marL="0">
-              <a:buNone/>
-            </a:pPr>
-            <a:r>
-              <a:rPr lang="en-US" sz="1200" dirty="0">
-                <a:solidFill>
-                  <a:srgbClr val="15222A"/>
-                </a:solidFill>
-                <a:latin typeface="Calibri" pitchFamily="34" charset="0"/>
-                <a:ea typeface="Calibri" pitchFamily="34" charset="-122"/>
-                <a:cs typeface="Calibri" pitchFamily="34" charset="-120"/>
-              </a:rPr>
-              <a:t>demurrage with real-time visibility (Stowage Plan)</a:t>
-            </a:r>
-            <a:endParaRPr lang="en-US" sz="1200" dirty="0"/>
-          </a:p>
-        </p:txBody>
-      </p:sp>
-      <p:sp>
-        <p:nvSpPr>
-          <p:cNvPr id="26" name="Basis note"/>
-          <p:cNvSpPr txBox="1"/>
-          <p:nvPr/>
-        </p:nvSpPr>
-        <p:spPr>
-          <a:xfrm>
-            <a:off x="548640" y="5943600"/>
-            <a:ext cx="11064240" cy="411480"/>
+            <a:off x="548640" y="5806440"/>
+            <a:ext cx="11064240" cy="548640"/>
           </a:xfrm>
           <a:prstGeom prst="rect">
             <a:avLst/>
@@ -7425,7 +7154,7 @@
                 <a:ea typeface="Calibri" pitchFamily="34" charset="-122"/>
                 <a:cs typeface="Calibri" pitchFamily="34" charset="-120"/>
               </a:rPr>
-              <a:t>TAT = elapsed time (a day is taken as 24 hours). A TAT reduction is not converted to FTE or rupees: the project list gives no frequency. SMP2's figures are for September 2026 as given by the owner and are not multiplied up to a year.</a:t>
+              <a:t>TAT = elapsed time (a day is taken as 24 hours). A TAT reduction is not converted to FTE or rupees: the project list gives no frequency. The heat-cycle figures are what the analysis shows is recoverable, from one month, for a project that is still in progress: they are a potential, not a result.</a:t>
             </a:r>
             <a:endParaRPr lang="en-US" sz="1100" dirty="0"/>
           </a:p>
@@ -7474,693 +7203,6 @@
             <a:fld id="{F7021451-1387-4CA6-816F-3879F97B5CBC}" type="slidenum">
               <a:rPr b="0" lang="en-US"/>
               <a:t>4</a:t>
-            </a:fld>
-            <a:endParaRPr lang="en-US"/>
-          </a:p>
-        </p:txBody>
-      </p:sp>
-    </p:spTree>
-  </p:cSld>
-  <p:clrMapOvr>
-    <a:masterClrMapping/>
-  </p:clrMapOvr>
-</p:sld>
-</file>
-
-<file path=ppt/slides/slide5.xml><?xml version="1.0" encoding="utf-8"?>
-<p:sld xmlns:a="http://schemas.openxmlformats.org/drawingml/2006/main" xmlns:r="http://schemas.openxmlformats.org/officeDocument/2006/relationships" xmlns:p="http://schemas.openxmlformats.org/presentationml/2006/main">
-  <p:cSld name="Slide 5">
-    <p:spTree>
-      <p:nvGrpSpPr>
-        <p:cNvPr id="1" name=""/>
-        <p:cNvGrpSpPr/>
-        <p:nvPr/>
-      </p:nvGrpSpPr>
-      <p:grpSpPr>
-        <a:xfrm>
-          <a:off x="0" y="0"/>
-          <a:ext cx="0" cy="0"/>
-          <a:chOff x="0" y="0"/>
-          <a:chExt cx="0" cy="0"/>
-        </a:xfrm>
-      </p:grpSpPr>
-      <p:sp>
-        <p:nvSpPr>
-          <p:cNvPr id="2" name="Text 0"/>
-          <p:cNvSpPr/>
-          <p:nvPr>
-            <p:ph idx="100" type="title" hasCustomPrompt="1"/>
-          </p:nvPr>
-        </p:nvSpPr>
-        <p:spPr>
-          <a:xfrm>
-            <a:off x="548640" y="320040"/>
-            <a:ext cx="11064240" cy="731520"/>
-          </a:xfrm>
-          <a:prstGeom prst="rect">
-            <a:avLst/>
-          </a:prstGeom>
-          <a:noFill/>
-          <a:ln/>
-        </p:spPr>
-        <p:txBody>
-          <a:bodyPr wrap="square" lIns="0" tIns="0" rIns="0" bIns="0" rtlCol="0" anchor="ctr"/>
-          <a:lstStyle/>
-          <a:p>
-            <a:pPr algn="l" indent="0" marL="0">
-              <a:buNone/>
-            </a:pPr>
-            <a:r>
-              <a:rPr lang="en-US" sz="3000" b="1" dirty="0">
-                <a:solidFill>
-                  <a:srgbClr val="15222A"/>
-                </a:solidFill>
-                <a:latin typeface="Calibri" pitchFamily="34" charset="0"/>
-                <a:ea typeface="Calibri" pitchFamily="34" charset="-122"/>
-                <a:cs typeface="Calibri" pitchFamily="34" charset="-120"/>
-              </a:rPr>
-              <a:t>What is stated, what is derived, and what is still missing</a:t>
-            </a:r>
-            <a:endParaRPr lang="en-US" sz="3000" dirty="0"/>
-          </a:p>
-        </p:txBody>
-      </p:sp>
-      <p:sp>
-        <p:nvSpPr>
-          <p:cNvPr id="3" name="STATED card"/>
-          <p:cNvSpPr/>
-          <p:nvPr/>
-        </p:nvSpPr>
-        <p:spPr>
-          <a:xfrm>
-            <a:off x="548640" y="1280160"/>
-            <a:ext cx="3611880" cy="3246120"/>
-          </a:xfrm>
-          <a:prstGeom prst="rect">
-            <a:avLst/>
-          </a:prstGeom>
-          <a:solidFill>
-            <a:srgbClr val="EEF3F5"/>
-          </a:solidFill>
-          <a:ln w="9525">
-            <a:solidFill>
-              <a:srgbClr val="D3DBE0"/>
-            </a:solidFill>
-            <a:prstDash val="solid"/>
-          </a:ln>
-        </p:spPr>
-      </p:sp>
-      <p:sp>
-        <p:nvSpPr>
-          <p:cNvPr id="4" name="STATED heading"/>
-          <p:cNvSpPr txBox="1"/>
-          <p:nvPr/>
-        </p:nvSpPr>
-        <p:spPr>
-          <a:xfrm>
-            <a:off x="731520" y="1371600"/>
-            <a:ext cx="3246120" cy="320040"/>
-          </a:xfrm>
-          <a:prstGeom prst="rect">
-            <a:avLst/>
-          </a:prstGeom>
-          <a:noFill/>
-          <a:ln/>
-        </p:spPr>
-        <p:txBody>
-          <a:bodyPr wrap="square" lIns="0" tIns="0" rIns="0" bIns="0" rtlCol="0" anchor="ctr"/>
-          <a:lstStyle/>
-          <a:p>
-            <a:pPr indent="0" marL="0">
-              <a:buNone/>
-            </a:pPr>
-            <a:r>
-              <a:rPr lang="en-US" sz="1400" b="1" dirty="0">
-                <a:solidFill>
-                  <a:srgbClr val="1F7A45"/>
-                </a:solidFill>
-                <a:latin typeface="Calibri" pitchFamily="34" charset="0"/>
-                <a:ea typeface="Calibri" pitchFamily="34" charset="-122"/>
-                <a:cs typeface="Calibri" pitchFamily="34" charset="-120"/>
-              </a:rPr>
-              <a:t>STATED</a:t>
-            </a:r>
-            <a:endParaRPr lang="en-US" sz="1400" dirty="0"/>
-          </a:p>
-        </p:txBody>
-      </p:sp>
-      <p:sp>
-        <p:nvSpPr>
-          <p:cNvPr id="5" name="STATED text"/>
-          <p:cNvSpPr txBox="1"/>
-          <p:nvPr/>
-        </p:nvSpPr>
-        <p:spPr>
-          <a:xfrm>
-            <a:off x="731520" y="1737360"/>
-            <a:ext cx="3246120" cy="2697480"/>
-          </a:xfrm>
-          <a:prstGeom prst="rect">
-            <a:avLst/>
-          </a:prstGeom>
-          <a:noFill/>
-          <a:ln/>
-        </p:spPr>
-        <p:txBody>
-          <a:bodyPr wrap="square" lIns="0" tIns="0" rIns="0" bIns="0" rtlCol="0" anchor="t"/>
-          <a:lstStyle/>
-          <a:p>
-            <a:pPr marL="342900" indent="-342900">
-              <a:spcAft>
-                <a:spcPts val="600"/>
-              </a:spcAft>
-              <a:buSzPct val="100000"/>
-              <a:buChar char="•"/>
-            </a:pPr>
-            <a:r>
-              <a:rPr lang="en-US" sz="1300" dirty="0">
-                <a:solidFill>
-                  <a:srgbClr val="15222A"/>
-                </a:solidFill>
-                <a:latin typeface="Calibri" pitchFamily="34" charset="0"/>
-                <a:ea typeface="Calibri" pitchFamily="34" charset="-122"/>
-                <a:cs typeface="Calibri" pitchFamily="34" charset="-120"/>
-              </a:rPr>
-              <a:t>Before and after figures quoted from the project list: 10 figures from 9 project entries.</a:t>
-            </a:r>
-            <a:endParaRPr lang="en-US" sz="1300" dirty="0"/>
-          </a:p>
-          <a:p>
-            <a:pPr marL="342900" indent="-342900">
-              <a:spcAft>
-                <a:spcPts val="600"/>
-              </a:spcAft>
-              <a:buSzPct val="100000"/>
-              <a:buChar char="•"/>
-            </a:pPr>
-            <a:r>
-              <a:rPr lang="en-US" sz="1300" dirty="0">
-                <a:solidFill>
-                  <a:srgbClr val="15222A"/>
-                </a:solidFill>
-                <a:latin typeface="Calibri" pitchFamily="34" charset="0"/>
-                <a:ea typeface="Calibri" pitchFamily="34" charset="-122"/>
-                <a:cs typeface="Calibri" pitchFamily="34" charset="-120"/>
-              </a:rPr>
-              <a:t>Paradeep Ports and SMP2 Digital Transformation, as given by their owners (not in the July list).</a:t>
-            </a:r>
-            <a:endParaRPr lang="en-US" sz="1300" dirty="0"/>
-          </a:p>
-          <a:p>
-            <a:pPr marL="342900" indent="-342900">
-              <a:spcAft>
-                <a:spcPts val="600"/>
-              </a:spcAft>
-              <a:buSzPct val="100000"/>
-              <a:buChar char="•"/>
-            </a:pPr>
-            <a:r>
-              <a:rPr lang="en-US" sz="1300" dirty="0">
-                <a:solidFill>
-                  <a:srgbClr val="15222A"/>
-                </a:solidFill>
-                <a:latin typeface="Calibri" pitchFamily="34" charset="0"/>
-                <a:ea typeface="Calibri" pitchFamily="34" charset="-122"/>
-                <a:cs typeface="Calibri" pitchFamily="34" charset="-120"/>
-              </a:rPr>
-              <a:t>Hours saved, TAT, heats and tons: as written, never multiplied up.</a:t>
-            </a:r>
-            <a:endParaRPr lang="en-US" sz="1300" dirty="0"/>
-          </a:p>
-        </p:txBody>
-      </p:sp>
-      <p:sp>
-        <p:nvSpPr>
-          <p:cNvPr id="6" name="DERIVED card"/>
-          <p:cNvSpPr/>
-          <p:nvPr/>
-        </p:nvSpPr>
-        <p:spPr>
-          <a:xfrm>
-            <a:off x="4297680" y="1280160"/>
-            <a:ext cx="3611880" cy="3246120"/>
-          </a:xfrm>
-          <a:prstGeom prst="rect">
-            <a:avLst/>
-          </a:prstGeom>
-          <a:solidFill>
-            <a:srgbClr val="EEF3F5"/>
-          </a:solidFill>
-          <a:ln w="9525">
-            <a:solidFill>
-              <a:srgbClr val="D3DBE0"/>
-            </a:solidFill>
-            <a:prstDash val="solid"/>
-          </a:ln>
-        </p:spPr>
-      </p:sp>
-      <p:sp>
-        <p:nvSpPr>
-          <p:cNvPr id="7" name="DERIVED heading"/>
-          <p:cNvSpPr txBox="1"/>
-          <p:nvPr/>
-        </p:nvSpPr>
-        <p:spPr>
-          <a:xfrm>
-            <a:off x="4480560" y="1371600"/>
-            <a:ext cx="3246120" cy="320040"/>
-          </a:xfrm>
-          <a:prstGeom prst="rect">
-            <a:avLst/>
-          </a:prstGeom>
-          <a:noFill/>
-          <a:ln/>
-        </p:spPr>
-        <p:txBody>
-          <a:bodyPr wrap="square" lIns="0" tIns="0" rIns="0" bIns="0" rtlCol="0" anchor="ctr"/>
-          <a:lstStyle/>
-          <a:p>
-            <a:pPr indent="0" marL="0">
-              <a:buNone/>
-            </a:pPr>
-            <a:r>
-              <a:rPr lang="en-US" sz="1400" b="1" dirty="0">
-                <a:solidFill>
-                  <a:srgbClr val="8A5F00"/>
-                </a:solidFill>
-                <a:latin typeface="Calibri" pitchFamily="34" charset="0"/>
-                <a:ea typeface="Calibri" pitchFamily="34" charset="-122"/>
-                <a:cs typeface="Calibri" pitchFamily="34" charset="-120"/>
-              </a:rPr>
-              <a:t>DERIVED</a:t>
-            </a:r>
-            <a:endParaRPr lang="en-US" sz="1400" dirty="0"/>
-          </a:p>
-        </p:txBody>
-      </p:sp>
-      <p:sp>
-        <p:nvSpPr>
-          <p:cNvPr id="8" name="DERIVED text"/>
-          <p:cNvSpPr txBox="1"/>
-          <p:nvPr/>
-        </p:nvSpPr>
-        <p:spPr>
-          <a:xfrm>
-            <a:off x="4480560" y="1737360"/>
-            <a:ext cx="3246120" cy="2697480"/>
-          </a:xfrm>
-          <a:prstGeom prst="rect">
-            <a:avLst/>
-          </a:prstGeom>
-          <a:noFill/>
-          <a:ln/>
-        </p:spPr>
-        <p:txBody>
-          <a:bodyPr wrap="square" lIns="0" tIns="0" rIns="0" bIns="0" rtlCol="0" anchor="t"/>
-          <a:lstStyle/>
-          <a:p>
-            <a:pPr marL="342900" indent="-342900">
-              <a:spcAft>
-                <a:spcPts val="600"/>
-              </a:spcAft>
-              <a:buSzPct val="100000"/>
-              <a:buChar char="•"/>
-            </a:pPr>
-            <a:r>
-              <a:rPr lang="en-US" sz="1300" dirty="0">
-                <a:solidFill>
-                  <a:srgbClr val="15222A"/>
-                </a:solidFill>
-                <a:latin typeface="Calibri" pitchFamily="34" charset="0"/>
-                <a:ea typeface="Calibri" pitchFamily="34" charset="-122"/>
-                <a:cs typeface="Calibri" pitchFamily="34" charset="-120"/>
-              </a:rPr>
-              <a:t>Cost of the 120 listed projects with the estimator's standard costing (one person, working days between dates, default masters, 3 years).</a:t>
-            </a:r>
-            <a:endParaRPr lang="en-US" sz="1300" dirty="0"/>
-          </a:p>
-          <a:p>
-            <a:pPr marL="342900" indent="-342900">
-              <a:spcAft>
-                <a:spcPts val="600"/>
-              </a:spcAft>
-              <a:buSzPct val="100000"/>
-              <a:buChar char="•"/>
-            </a:pPr>
-            <a:r>
-              <a:rPr lang="en-US" sz="1300" dirty="0">
-                <a:solidFill>
-                  <a:srgbClr val="15222A"/>
-                </a:solidFill>
-                <a:latin typeface="Calibri" pitchFamily="34" charset="0"/>
-                <a:ea typeface="Calibri" pitchFamily="34" charset="-122"/>
-                <a:cs typeface="Calibri" pitchFamily="34" charset="-120"/>
-              </a:rPr>
-              <a:t>Avoided cost = software-company price minus in-house cost.</a:t>
-            </a:r>
-            <a:endParaRPr lang="en-US" sz="1300" dirty="0"/>
-          </a:p>
-          <a:p>
-            <a:pPr marL="342900" indent="-342900">
-              <a:spcAft>
-                <a:spcPts val="600"/>
-              </a:spcAft>
-              <a:buSzPct val="100000"/>
-              <a:buChar char="•"/>
-            </a:pPr>
-            <a:r>
-              <a:rPr lang="en-US" sz="1300" dirty="0">
-                <a:solidFill>
-                  <a:srgbClr val="15222A"/>
-                </a:solidFill>
-                <a:latin typeface="Calibri" pitchFamily="34" charset="0"/>
-                <a:ea typeface="Calibri" pitchFamily="34" charset="-122"/>
-                <a:cs typeface="Calibri" pitchFamily="34" charset="-120"/>
-              </a:rPr>
-              <a:t>FTE = hours / 2,740. Paradeep's ₹ value and payback use the ₹6,000 Mid man-day rate.</a:t>
-            </a:r>
-            <a:endParaRPr lang="en-US" sz="1300" dirty="0"/>
-          </a:p>
-        </p:txBody>
-      </p:sp>
-      <p:sp>
-        <p:nvSpPr>
-          <p:cNvPr id="9" name="STILL MISSING card"/>
-          <p:cNvSpPr/>
-          <p:nvPr/>
-        </p:nvSpPr>
-        <p:spPr>
-          <a:xfrm>
-            <a:off x="8046720" y="1280160"/>
-            <a:ext cx="3611880" cy="3246120"/>
-          </a:xfrm>
-          <a:prstGeom prst="rect">
-            <a:avLst/>
-          </a:prstGeom>
-          <a:solidFill>
-            <a:srgbClr val="EEF3F5"/>
-          </a:solidFill>
-          <a:ln w="9525">
-            <a:solidFill>
-              <a:srgbClr val="D3DBE0"/>
-            </a:solidFill>
-            <a:prstDash val="solid"/>
-          </a:ln>
-        </p:spPr>
-      </p:sp>
-      <p:sp>
-        <p:nvSpPr>
-          <p:cNvPr id="10" name="STILL MISSING heading"/>
-          <p:cNvSpPr txBox="1"/>
-          <p:nvPr/>
-        </p:nvSpPr>
-        <p:spPr>
-          <a:xfrm>
-            <a:off x="8229600" y="1371600"/>
-            <a:ext cx="3246120" cy="320040"/>
-          </a:xfrm>
-          <a:prstGeom prst="rect">
-            <a:avLst/>
-          </a:prstGeom>
-          <a:noFill/>
-          <a:ln/>
-        </p:spPr>
-        <p:txBody>
-          <a:bodyPr wrap="square" lIns="0" tIns="0" rIns="0" bIns="0" rtlCol="0" anchor="ctr"/>
-          <a:lstStyle/>
-          <a:p>
-            <a:pPr indent="0" marL="0">
-              <a:buNone/>
-            </a:pPr>
-            <a:r>
-              <a:rPr lang="en-US" sz="1400" b="1" dirty="0">
-                <a:solidFill>
-                  <a:srgbClr val="B3411A"/>
-                </a:solidFill>
-                <a:latin typeface="Calibri" pitchFamily="34" charset="0"/>
-                <a:ea typeface="Calibri" pitchFamily="34" charset="-122"/>
-                <a:cs typeface="Calibri" pitchFamily="34" charset="-120"/>
-              </a:rPr>
-              <a:t>STILL MISSING</a:t>
-            </a:r>
-            <a:endParaRPr lang="en-US" sz="1400" dirty="0"/>
-          </a:p>
-        </p:txBody>
-      </p:sp>
-      <p:sp>
-        <p:nvSpPr>
-          <p:cNvPr id="11" name="STILL MISSING text"/>
-          <p:cNvSpPr txBox="1"/>
-          <p:nvPr/>
-        </p:nvSpPr>
-        <p:spPr>
-          <a:xfrm>
-            <a:off x="8229600" y="1737360"/>
-            <a:ext cx="3246120" cy="2697480"/>
-          </a:xfrm>
-          <a:prstGeom prst="rect">
-            <a:avLst/>
-          </a:prstGeom>
-          <a:noFill/>
-          <a:ln/>
-        </p:spPr>
-        <p:txBody>
-          <a:bodyPr wrap="square" lIns="0" tIns="0" rIns="0" bIns="0" rtlCol="0" anchor="t"/>
-          <a:lstStyle/>
-          <a:p>
-            <a:pPr marL="342900" indent="-342900">
-              <a:spcAft>
-                <a:spcPts val="600"/>
-              </a:spcAft>
-              <a:buSzPct val="100000"/>
-              <a:buChar char="•"/>
-            </a:pPr>
-            <a:r>
-              <a:rPr lang="en-US" sz="1300" dirty="0">
-                <a:solidFill>
-                  <a:srgbClr val="15222A"/>
-                </a:solidFill>
-                <a:latin typeface="Calibri" pitchFamily="34" charset="0"/>
-                <a:ea typeface="Calibri" pitchFamily="34" charset="-122"/>
-                <a:cs typeface="Calibri" pitchFamily="34" charset="-120"/>
-              </a:rPr>
-              <a:t>No rupee gain (Cal-2) is recorded for these projects; Efforts Saving (man-hours) is empty.</a:t>
-            </a:r>
-            <a:endParaRPr lang="en-US" sz="1300" dirty="0"/>
-          </a:p>
-          <a:p>
-            <a:pPr marL="342900" indent="-342900">
-              <a:spcAft>
-                <a:spcPts val="600"/>
-              </a:spcAft>
-              <a:buSzPct val="100000"/>
-              <a:buChar char="•"/>
-            </a:pPr>
-            <a:r>
-              <a:rPr lang="en-US" sz="1300" dirty="0">
-                <a:solidFill>
-                  <a:srgbClr val="15222A"/>
-                </a:solidFill>
-                <a:latin typeface="Calibri" pitchFamily="34" charset="0"/>
-                <a:ea typeface="Calibri" pitchFamily="34" charset="-122"/>
-                <a:cs typeface="Calibri" pitchFamily="34" charset="-120"/>
-              </a:rPr>
-              <a:t>47 of 120 listed projects have no benefit text at all.</a:t>
-            </a:r>
-            <a:endParaRPr lang="en-US" sz="1300" dirty="0"/>
-          </a:p>
-          <a:p>
-            <a:pPr marL="342900" indent="-342900">
-              <a:spcAft>
-                <a:spcPts val="600"/>
-              </a:spcAft>
-              <a:buSzPct val="100000"/>
-              <a:buChar char="•"/>
-            </a:pPr>
-            <a:r>
-              <a:rPr lang="en-US" sz="1300" dirty="0">
-                <a:solidFill>
-                  <a:srgbClr val="15222A"/>
-                </a:solidFill>
-                <a:latin typeface="Calibri" pitchFamily="34" charset="0"/>
-                <a:ea typeface="Calibri" pitchFamily="34" charset="-122"/>
-                <a:cs typeface="Calibri" pitchFamily="34" charset="-120"/>
-              </a:rPr>
-              <a:t>SMP2 has no cost, and no yearly figure (September only). The status of both added projects was not given: treated as live.</a:t>
-            </a:r>
-            <a:endParaRPr lang="en-US" sz="1300" dirty="0"/>
-          </a:p>
-        </p:txBody>
-      </p:sp>
-      <p:sp>
-        <p:nvSpPr>
-          <p:cNvPr id="12" name="Ask card"/>
-          <p:cNvSpPr/>
-          <p:nvPr/>
-        </p:nvSpPr>
-        <p:spPr>
-          <a:xfrm>
-            <a:off x="548640" y="4663440"/>
-            <a:ext cx="11064240" cy="1097280"/>
-          </a:xfrm>
-          <a:prstGeom prst="rect">
-            <a:avLst/>
-          </a:prstGeom>
-          <a:solidFill>
-            <a:srgbClr val="FFF8E6"/>
-          </a:solidFill>
-          <a:ln w="12700">
-            <a:solidFill>
-              <a:srgbClr val="E4B33E"/>
-            </a:solidFill>
-            <a:prstDash val="solid"/>
-          </a:ln>
-        </p:spPr>
-      </p:sp>
-      <p:sp>
-        <p:nvSpPr>
-          <p:cNvPr id="13" name="Ask text"/>
-          <p:cNvSpPr txBox="1"/>
-          <p:nvPr/>
-        </p:nvSpPr>
-        <p:spPr>
-          <a:xfrm>
-            <a:off x="731520" y="4736592"/>
-            <a:ext cx="10698480" cy="960120"/>
-          </a:xfrm>
-          <a:prstGeom prst="rect">
-            <a:avLst/>
-          </a:prstGeom>
-          <a:noFill/>
-          <a:ln/>
-        </p:spPr>
-        <p:txBody>
-          <a:bodyPr wrap="square" lIns="0" tIns="0" rIns="0" bIns="0" rtlCol="0" anchor="ctr"/>
-          <a:lstStyle/>
-          <a:p>
-            <a:pPr indent="0" marL="0">
-              <a:spcAft>
-                <a:spcPts val="400"/>
-              </a:spcAft>
-              <a:buNone/>
-            </a:pPr>
-            <a:r>
-              <a:rPr lang="en-US" sz="1300" b="1" dirty="0">
-                <a:solidFill>
-                  <a:srgbClr val="15222A"/>
-                </a:solidFill>
-                <a:latin typeface="Calibri" pitchFamily="34" charset="0"/>
-                <a:ea typeface="Calibri" pitchFamily="34" charset="-122"/>
-                <a:cs typeface="Calibri" pitchFamily="34" charset="-120"/>
-              </a:rPr>
-              <a:t>To turn these into yearly ₹, FTE and TAT totals, ask each project owner for one number: how often the task runs (shipments a year, reports a day, heats a month).</a:t>
-            </a:r>
-            <a:endParaRPr lang="en-US" sz="1300" dirty="0"/>
-          </a:p>
-          <a:p>
-            <a:pPr indent="0" marL="0">
-              <a:spcAft>
-                <a:spcPts val="400"/>
-              </a:spcAft>
-              <a:buNone/>
-            </a:pPr>
-            <a:r>
-              <a:rPr lang="en-US" sz="1300" dirty="0">
-                <a:solidFill>
-                  <a:srgbClr val="15222A"/>
-                </a:solidFill>
-                <a:latin typeface="Calibri" pitchFamily="34" charset="0"/>
-                <a:ea typeface="Calibri" pitchFamily="34" charset="-122"/>
-                <a:cs typeface="Calibri" pitchFamily="34" charset="-120"/>
-              </a:rPr>
-              <a:t>Then: saved time x runs per year x cost per hour. Money here is an avoided external price, not cash released; a project cost is an investment, not a saving.</a:t>
-            </a:r>
-            <a:endParaRPr lang="en-US" sz="1300" dirty="0"/>
-          </a:p>
-        </p:txBody>
-      </p:sp>
-      <p:sp>
-        <p:nvSpPr>
-          <p:cNvPr id="14" name="Basis note"/>
-          <p:cNvSpPr txBox="1"/>
-          <p:nvPr/>
-        </p:nvSpPr>
-        <p:spPr>
-          <a:xfrm>
-            <a:off x="548640" y="5897880"/>
-            <a:ext cx="11064240" cy="502920"/>
-          </a:xfrm>
-          <a:prstGeom prst="rect">
-            <a:avLst/>
-          </a:prstGeom>
-          <a:noFill/>
-          <a:ln/>
-        </p:spPr>
-        <p:txBody>
-          <a:bodyPr wrap="square" lIns="0" tIns="0" rIns="0" bIns="0" rtlCol="0" anchor="t"/>
-          <a:lstStyle/>
-          <a:p>
-            <a:pPr indent="0" marL="0">
-              <a:buNone/>
-            </a:pPr>
-            <a:r>
-              <a:rPr lang="en-US" sz="1100" dirty="0">
-                <a:solidFill>
-                  <a:srgbClr val="566872"/>
-                </a:solidFill>
-                <a:latin typeface="Calibri" pitchFamily="34" charset="0"/>
-                <a:ea typeface="Calibri" pitchFamily="34" charset="-122"/>
-                <a:cs typeface="Calibri" pitchFamily="34" charset="-120"/>
-              </a:rPr>
-              <a:t>Scope: listed projects whose dates overlap Nov 2025 to 29 October 2026, plus every project marked In Progress; 70 of 190 listed projects left out (dated outside the period and not in progress, no dates and not in progress, or failed). Source: CA_Projects_List_As_of_July_2026.xlsx and the owners' notes of 29 October 2026.</a:t>
-            </a:r>
-            <a:endParaRPr lang="en-US" sz="1100" dirty="0"/>
-          </a:p>
-        </p:txBody>
-      </p:sp>
-      <p:sp>
-        <p:nvSpPr>
-          <p:cNvPr id="25" name="Slide Number Placeholder 0"/>
-          <p:cNvSpPr>
-            <a:spLocks noGrp="1"/>
-          </p:cNvSpPr>
-          <p:nvPr>
-            <p:ph type="sldNum" sz="quarter" idx="4294967295"/>
-          </p:nvPr>
-        </p:nvSpPr>
-        <p:spPr>
-          <a:xfrm>
-            <a:off x="11155680" y="6473952"/>
-            <a:ext cx="502920" cy="274320"/>
-          </a:xfrm>
-          <a:prstGeom prst="rect">
-            <a:avLst/>
-          </a:prstGeom>
-          <a:extLst>
-            <a:ext uri="{C572A759-6A51-4108-AA02-DFA0A04FC94B}">
-              <ma14:wrappingTextBoxFlag xmlns:ma14="http://schemas.microsoft.com/office/mac/drawingml/2011/main" val="0"/>
-            </a:ext>
-          </a:extLst>
-        </p:spPr>
-        <p:txBody>
-          <a:bodyPr/>
-          <a:lstStyle>
-            <a:lvl1pPr>
-              <a:defRPr sz="1000">
-                <a:solidFill>
-                  <a:srgbClr val="566872"/>
-                </a:solidFill>
-                <a:latin typeface="Calibri"/>
-                <a:ea typeface="Calibri"/>
-                <a:cs typeface="Calibri"/>
-              </a:defRPr>
-            </a:lvl1pPr>
-          </a:lstStyle>
-          <a:p>
-            <a:pPr algn="r"/>
-            <a:fld id="{F7021451-1387-4CA6-816F-3879F97B5CBC}" type="slidenum">
-              <a:rPr b="0" lang="en-US"/>
-              <a:t>5</a:t>
             </a:fld>
             <a:endParaRPr lang="en-US"/>
           </a:p>

</xml_diff>